<commit_message>
(3.6) 프리펩 및 후처리(Post Processing) + 카메라 효과
</commit_message>
<xml_diff>
--- a/(3.6) 프리펩.pptx
+++ b/(3.6) 프리펩.pptx
@@ -6,6 +6,15 @@
   </p:sldMasterIdLst>
   <p:sldIdLst>
     <p:sldId id="257" r:id="rId2"/>
+    <p:sldId id="258" r:id="rId3"/>
+    <p:sldId id="259" r:id="rId4"/>
+    <p:sldId id="260" r:id="rId5"/>
+    <p:sldId id="261" r:id="rId6"/>
+    <p:sldId id="262" r:id="rId7"/>
+    <p:sldId id="263" r:id="rId8"/>
+    <p:sldId id="264" r:id="rId9"/>
+    <p:sldId id="265" r:id="rId10"/>
+    <p:sldId id="266" r:id="rId11"/>
   </p:sldIdLst>
   <p:sldSz cx="12192000" cy="6858000"/>
   <p:notesSz cx="6858000" cy="9144000"/>
@@ -104,15 +113,28 @@
       </a:defRPr>
     </a:lvl9pPr>
   </p:defaultTextStyle>
+  <p:extLst>
+    <p:ext uri="{EFAFB233-063F-42B5-8137-9DF3F51BA10A}">
+      <p15:sldGuideLst xmlns:p15="http://schemas.microsoft.com/office/powerpoint/2012/main"/>
+    </p:ext>
+  </p:extLst>
 </p:presentation>
+</file>
+
+<file path=ppt/revisionInfo.xml><?xml version="1.0" encoding="utf-8"?>
+<p1510:revInfo xmlns:a="http://schemas.openxmlformats.org/drawingml/2006/main" xmlns:r="http://schemas.openxmlformats.org/officeDocument/2006/relationships" xmlns:p1510="http://schemas.microsoft.com/office/powerpoint/2015/10/main">
+  <p1510:revLst>
+    <p1510:client id="{39B1E4A5-C5DD-4FE2-A907-C0C52A2D94FE}" v="63" dt="2026-03-06T06:26:00.094"/>
+  </p1510:revLst>
+</p1510:revInfo>
 </file>
 
 <file path=ppt/changesInfos/changesInfo1.xml><?xml version="1.0" encoding="utf-8"?>
 <pc:chgInfo xmlns:a="http://schemas.openxmlformats.org/drawingml/2006/main" xmlns:r="http://schemas.openxmlformats.org/officeDocument/2006/relationships" xmlns:ac="http://schemas.microsoft.com/office/drawing/2013/main/command" xmlns:pc="http://schemas.microsoft.com/office/powerpoint/2013/main/command">
   <pc:docChgLst>
     <pc:chgData name="musukie52@gmail.com" userId="017bd91f96aa8751" providerId="LiveId" clId="{5B2C3894-F97E-4CAB-8812-5BB4D83AAC6A}"/>
-    <pc:docChg chg="addSld delSld">
-      <pc:chgData name="musukie52@gmail.com" userId="017bd91f96aa8751" providerId="LiveId" clId="{5B2C3894-F97E-4CAB-8812-5BB4D83AAC6A}" dt="2026-03-06T04:53:47.739" v="2" actId="47"/>
+    <pc:docChg chg="undo custSel addSld delSld modSld">
+      <pc:chgData name="musukie52@gmail.com" userId="017bd91f96aa8751" providerId="LiveId" clId="{5B2C3894-F97E-4CAB-8812-5BB4D83AAC6A}" dt="2026-03-06T06:26:05.480" v="8061" actId="20577"/>
       <pc:docMkLst>
         <pc:docMk/>
       </pc:docMkLst>
@@ -123,12 +145,251 @@
           <pc:sldMk cId="1498838948" sldId="256"/>
         </pc:sldMkLst>
       </pc:sldChg>
-      <pc:sldChg chg="new">
-        <pc:chgData name="musukie52@gmail.com" userId="017bd91f96aa8751" providerId="LiveId" clId="{5B2C3894-F97E-4CAB-8812-5BB4D83AAC6A}" dt="2026-03-06T04:53:46.752" v="1" actId="680"/>
+      <pc:sldChg chg="addSp modSp new mod">
+        <pc:chgData name="musukie52@gmail.com" userId="017bd91f96aa8751" providerId="LiveId" clId="{5B2C3894-F97E-4CAB-8812-5BB4D83AAC6A}" dt="2026-03-06T05:51:38.559" v="3679" actId="20577"/>
         <pc:sldMkLst>
           <pc:docMk/>
           <pc:sldMk cId="850242358" sldId="257"/>
         </pc:sldMkLst>
+        <pc:spChg chg="mod">
+          <ac:chgData name="musukie52@gmail.com" userId="017bd91f96aa8751" providerId="LiveId" clId="{5B2C3894-F97E-4CAB-8812-5BB4D83AAC6A}" dt="2026-03-06T05:17:26.626" v="81" actId="20577"/>
+          <ac:spMkLst>
+            <pc:docMk/>
+            <pc:sldMk cId="850242358" sldId="257"/>
+            <ac:spMk id="2" creationId="{260EA268-9F94-50F2-1AB7-293B322CC912}"/>
+          </ac:spMkLst>
+        </pc:spChg>
+        <pc:spChg chg="mod">
+          <ac:chgData name="musukie52@gmail.com" userId="017bd91f96aa8751" providerId="LiveId" clId="{5B2C3894-F97E-4CAB-8812-5BB4D83AAC6A}" dt="2026-03-06T05:51:01.102" v="3459" actId="14100"/>
+          <ac:spMkLst>
+            <pc:docMk/>
+            <pc:sldMk cId="850242358" sldId="257"/>
+            <ac:spMk id="3" creationId="{E67AEBB0-1ED4-FA30-2EFE-074D5FA8CB7F}"/>
+          </ac:spMkLst>
+        </pc:spChg>
+        <pc:spChg chg="add mod">
+          <ac:chgData name="musukie52@gmail.com" userId="017bd91f96aa8751" providerId="LiveId" clId="{5B2C3894-F97E-4CAB-8812-5BB4D83AAC6A}" dt="2026-03-06T05:50:55.819" v="3458" actId="20577"/>
+          <ac:spMkLst>
+            <pc:docMk/>
+            <pc:sldMk cId="850242358" sldId="257"/>
+            <ac:spMk id="4" creationId="{FA52AAAC-0260-6B5F-96A4-13BCA931000D}"/>
+          </ac:spMkLst>
+        </pc:spChg>
+        <pc:spChg chg="add mod">
+          <ac:chgData name="musukie52@gmail.com" userId="017bd91f96aa8751" providerId="LiveId" clId="{5B2C3894-F97E-4CAB-8812-5BB4D83AAC6A}" dt="2026-03-06T05:51:38.559" v="3679" actId="20577"/>
+          <ac:spMkLst>
+            <pc:docMk/>
+            <pc:sldMk cId="850242358" sldId="257"/>
+            <ac:spMk id="5" creationId="{81B607D6-3AAF-6960-9D9F-D0CA6F0577B6}"/>
+          </ac:spMkLst>
+        </pc:spChg>
+      </pc:sldChg>
+      <pc:sldChg chg="modSp new mod">
+        <pc:chgData name="musukie52@gmail.com" userId="017bd91f96aa8751" providerId="LiveId" clId="{5B2C3894-F97E-4CAB-8812-5BB4D83AAC6A}" dt="2026-03-06T05:36:27.659" v="1818" actId="20577"/>
+        <pc:sldMkLst>
+          <pc:docMk/>
+          <pc:sldMk cId="2981630723" sldId="258"/>
+        </pc:sldMkLst>
+        <pc:spChg chg="mod">
+          <ac:chgData name="musukie52@gmail.com" userId="017bd91f96aa8751" providerId="LiveId" clId="{5B2C3894-F97E-4CAB-8812-5BB4D83AAC6A}" dt="2026-03-06T05:27:56.251" v="347" actId="20577"/>
+          <ac:spMkLst>
+            <pc:docMk/>
+            <pc:sldMk cId="2981630723" sldId="258"/>
+            <ac:spMk id="2" creationId="{3A0DD556-6D1F-B217-6D4E-0E3106444940}"/>
+          </ac:spMkLst>
+        </pc:spChg>
+        <pc:spChg chg="mod">
+          <ac:chgData name="musukie52@gmail.com" userId="017bd91f96aa8751" providerId="LiveId" clId="{5B2C3894-F97E-4CAB-8812-5BB4D83AAC6A}" dt="2026-03-06T05:36:27.659" v="1818" actId="20577"/>
+          <ac:spMkLst>
+            <pc:docMk/>
+            <pc:sldMk cId="2981630723" sldId="258"/>
+            <ac:spMk id="3" creationId="{37DFC9F1-F6D2-9916-8C6E-8B0A5AD6BB7A}"/>
+          </ac:spMkLst>
+        </pc:spChg>
+      </pc:sldChg>
+      <pc:sldChg chg="modSp new mod">
+        <pc:chgData name="musukie52@gmail.com" userId="017bd91f96aa8751" providerId="LiveId" clId="{5B2C3894-F97E-4CAB-8812-5BB4D83AAC6A}" dt="2026-03-06T05:36:03.062" v="1796" actId="20577"/>
+        <pc:sldMkLst>
+          <pc:docMk/>
+          <pc:sldMk cId="1955580070" sldId="259"/>
+        </pc:sldMkLst>
+        <pc:spChg chg="mod">
+          <ac:chgData name="musukie52@gmail.com" userId="017bd91f96aa8751" providerId="LiveId" clId="{5B2C3894-F97E-4CAB-8812-5BB4D83AAC6A}" dt="2026-03-06T05:32:53.586" v="1238" actId="20577"/>
+          <ac:spMkLst>
+            <pc:docMk/>
+            <pc:sldMk cId="1955580070" sldId="259"/>
+            <ac:spMk id="2" creationId="{8EF094E1-7868-478D-30C0-7760572E1A73}"/>
+          </ac:spMkLst>
+        </pc:spChg>
+        <pc:spChg chg="mod">
+          <ac:chgData name="musukie52@gmail.com" userId="017bd91f96aa8751" providerId="LiveId" clId="{5B2C3894-F97E-4CAB-8812-5BB4D83AAC6A}" dt="2026-03-06T05:36:03.062" v="1796" actId="20577"/>
+          <ac:spMkLst>
+            <pc:docMk/>
+            <pc:sldMk cId="1955580070" sldId="259"/>
+            <ac:spMk id="3" creationId="{CBE2A73A-37CB-05FF-D329-490AADDD59F4}"/>
+          </ac:spMkLst>
+        </pc:spChg>
+      </pc:sldChg>
+      <pc:sldChg chg="modSp new mod">
+        <pc:chgData name="musukie52@gmail.com" userId="017bd91f96aa8751" providerId="LiveId" clId="{5B2C3894-F97E-4CAB-8812-5BB4D83AAC6A}" dt="2026-03-06T05:50:30.237" v="3445" actId="20577"/>
+        <pc:sldMkLst>
+          <pc:docMk/>
+          <pc:sldMk cId="2089986495" sldId="260"/>
+        </pc:sldMkLst>
+        <pc:spChg chg="mod">
+          <ac:chgData name="musukie52@gmail.com" userId="017bd91f96aa8751" providerId="LiveId" clId="{5B2C3894-F97E-4CAB-8812-5BB4D83AAC6A}" dt="2026-03-06T05:40:49.052" v="1870" actId="20577"/>
+          <ac:spMkLst>
+            <pc:docMk/>
+            <pc:sldMk cId="2089986495" sldId="260"/>
+            <ac:spMk id="2" creationId="{F2316944-20F9-53E3-AFCE-C892274AB6C8}"/>
+          </ac:spMkLst>
+        </pc:spChg>
+        <pc:spChg chg="mod">
+          <ac:chgData name="musukie52@gmail.com" userId="017bd91f96aa8751" providerId="LiveId" clId="{5B2C3894-F97E-4CAB-8812-5BB4D83AAC6A}" dt="2026-03-06T05:50:30.237" v="3445" actId="20577"/>
+          <ac:spMkLst>
+            <pc:docMk/>
+            <pc:sldMk cId="2089986495" sldId="260"/>
+            <ac:spMk id="3" creationId="{9623A604-AE2D-6B2C-B521-5A7F280DF799}"/>
+          </ac:spMkLst>
+        </pc:spChg>
+      </pc:sldChg>
+      <pc:sldChg chg="modSp new mod">
+        <pc:chgData name="musukie52@gmail.com" userId="017bd91f96aa8751" providerId="LiveId" clId="{5B2C3894-F97E-4CAB-8812-5BB4D83AAC6A}" dt="2026-03-06T05:54:29.572" v="4341" actId="20577"/>
+        <pc:sldMkLst>
+          <pc:docMk/>
+          <pc:sldMk cId="1398924051" sldId="261"/>
+        </pc:sldMkLst>
+        <pc:spChg chg="mod">
+          <ac:chgData name="musukie52@gmail.com" userId="017bd91f96aa8751" providerId="LiveId" clId="{5B2C3894-F97E-4CAB-8812-5BB4D83AAC6A}" dt="2026-03-06T05:52:16.994" v="3705" actId="20577"/>
+          <ac:spMkLst>
+            <pc:docMk/>
+            <pc:sldMk cId="1398924051" sldId="261"/>
+            <ac:spMk id="2" creationId="{44DB9A97-90B0-AE13-65D6-E37B3ADD7A68}"/>
+          </ac:spMkLst>
+        </pc:spChg>
+        <pc:spChg chg="mod">
+          <ac:chgData name="musukie52@gmail.com" userId="017bd91f96aa8751" providerId="LiveId" clId="{5B2C3894-F97E-4CAB-8812-5BB4D83AAC6A}" dt="2026-03-06T05:54:29.572" v="4341" actId="20577"/>
+          <ac:spMkLst>
+            <pc:docMk/>
+            <pc:sldMk cId="1398924051" sldId="261"/>
+            <ac:spMk id="3" creationId="{B4407594-6D22-3AEE-188C-1645176B7FF3}"/>
+          </ac:spMkLst>
+        </pc:spChg>
+      </pc:sldChg>
+      <pc:sldChg chg="modSp new mod">
+        <pc:chgData name="musukie52@gmail.com" userId="017bd91f96aa8751" providerId="LiveId" clId="{5B2C3894-F97E-4CAB-8812-5BB4D83AAC6A}" dt="2026-03-06T05:56:43.551" v="5006" actId="5793"/>
+        <pc:sldMkLst>
+          <pc:docMk/>
+          <pc:sldMk cId="3596129955" sldId="262"/>
+        </pc:sldMkLst>
+        <pc:spChg chg="mod">
+          <ac:chgData name="musukie52@gmail.com" userId="017bd91f96aa8751" providerId="LiveId" clId="{5B2C3894-F97E-4CAB-8812-5BB4D83AAC6A}" dt="2026-03-06T05:54:42.618" v="4389" actId="20577"/>
+          <ac:spMkLst>
+            <pc:docMk/>
+            <pc:sldMk cId="3596129955" sldId="262"/>
+            <ac:spMk id="2" creationId="{30ABF29C-6B14-64C5-E35C-D6269D66E9F0}"/>
+          </ac:spMkLst>
+        </pc:spChg>
+        <pc:spChg chg="mod">
+          <ac:chgData name="musukie52@gmail.com" userId="017bd91f96aa8751" providerId="LiveId" clId="{5B2C3894-F97E-4CAB-8812-5BB4D83AAC6A}" dt="2026-03-06T05:56:43.551" v="5006" actId="5793"/>
+          <ac:spMkLst>
+            <pc:docMk/>
+            <pc:sldMk cId="3596129955" sldId="262"/>
+            <ac:spMk id="3" creationId="{EFED090A-EB0D-78CC-ADBA-2EDC9FCE8F90}"/>
+          </ac:spMkLst>
+        </pc:spChg>
+      </pc:sldChg>
+      <pc:sldChg chg="modSp new mod">
+        <pc:chgData name="musukie52@gmail.com" userId="017bd91f96aa8751" providerId="LiveId" clId="{5B2C3894-F97E-4CAB-8812-5BB4D83AAC6A}" dt="2026-03-06T05:57:56.907" v="5263" actId="20577"/>
+        <pc:sldMkLst>
+          <pc:docMk/>
+          <pc:sldMk cId="3646362785" sldId="263"/>
+        </pc:sldMkLst>
+        <pc:spChg chg="mod">
+          <ac:chgData name="musukie52@gmail.com" userId="017bd91f96aa8751" providerId="LiveId" clId="{5B2C3894-F97E-4CAB-8812-5BB4D83AAC6A}" dt="2026-03-06T05:57:05.911" v="5028" actId="20577"/>
+          <ac:spMkLst>
+            <pc:docMk/>
+            <pc:sldMk cId="3646362785" sldId="263"/>
+            <ac:spMk id="2" creationId="{08850BF9-D6A2-0952-1D95-FFAFBFCFA4E7}"/>
+          </ac:spMkLst>
+        </pc:spChg>
+        <pc:spChg chg="mod">
+          <ac:chgData name="musukie52@gmail.com" userId="017bd91f96aa8751" providerId="LiveId" clId="{5B2C3894-F97E-4CAB-8812-5BB4D83AAC6A}" dt="2026-03-06T05:57:56.907" v="5263" actId="20577"/>
+          <ac:spMkLst>
+            <pc:docMk/>
+            <pc:sldMk cId="3646362785" sldId="263"/>
+            <ac:spMk id="3" creationId="{A84B518F-0111-D807-BBEB-E7BBF694ABB2}"/>
+          </ac:spMkLst>
+        </pc:spChg>
+      </pc:sldChg>
+      <pc:sldChg chg="modSp new mod">
+        <pc:chgData name="musukie52@gmail.com" userId="017bd91f96aa8751" providerId="LiveId" clId="{5B2C3894-F97E-4CAB-8812-5BB4D83AAC6A}" dt="2026-03-06T06:12:18.468" v="6744" actId="20577"/>
+        <pc:sldMkLst>
+          <pc:docMk/>
+          <pc:sldMk cId="273460658" sldId="264"/>
+        </pc:sldMkLst>
+        <pc:spChg chg="mod">
+          <ac:chgData name="musukie52@gmail.com" userId="017bd91f96aa8751" providerId="LiveId" clId="{5B2C3894-F97E-4CAB-8812-5BB4D83AAC6A}" dt="2026-03-06T06:02:51.659" v="5294" actId="20577"/>
+          <ac:spMkLst>
+            <pc:docMk/>
+            <pc:sldMk cId="273460658" sldId="264"/>
+            <ac:spMk id="2" creationId="{A994B7AF-0E63-2A80-4C8A-63AE88D262F4}"/>
+          </ac:spMkLst>
+        </pc:spChg>
+        <pc:spChg chg="mod">
+          <ac:chgData name="musukie52@gmail.com" userId="017bd91f96aa8751" providerId="LiveId" clId="{5B2C3894-F97E-4CAB-8812-5BB4D83AAC6A}" dt="2026-03-06T06:12:18.468" v="6744" actId="20577"/>
+          <ac:spMkLst>
+            <pc:docMk/>
+            <pc:sldMk cId="273460658" sldId="264"/>
+            <ac:spMk id="3" creationId="{7449A69F-2474-F26B-8FD0-CF76F68B2AB1}"/>
+          </ac:spMkLst>
+        </pc:spChg>
+      </pc:sldChg>
+      <pc:sldChg chg="modSp new mod">
+        <pc:chgData name="musukie52@gmail.com" userId="017bd91f96aa8751" providerId="LiveId" clId="{5B2C3894-F97E-4CAB-8812-5BB4D83AAC6A}" dt="2026-03-06T06:16:52.746" v="7512" actId="113"/>
+        <pc:sldMkLst>
+          <pc:docMk/>
+          <pc:sldMk cId="3613664226" sldId="265"/>
+        </pc:sldMkLst>
+        <pc:spChg chg="mod">
+          <ac:chgData name="musukie52@gmail.com" userId="017bd91f96aa8751" providerId="LiveId" clId="{5B2C3894-F97E-4CAB-8812-5BB4D83AAC6A}" dt="2026-03-06T06:16:52.746" v="7512" actId="113"/>
+          <ac:spMkLst>
+            <pc:docMk/>
+            <pc:sldMk cId="3613664226" sldId="265"/>
+            <ac:spMk id="2" creationId="{569D7B29-B37B-3E2D-D415-976F1138F5DD}"/>
+          </ac:spMkLst>
+        </pc:spChg>
+        <pc:spChg chg="mod">
+          <ac:chgData name="musukie52@gmail.com" userId="017bd91f96aa8751" providerId="LiveId" clId="{5B2C3894-F97E-4CAB-8812-5BB4D83AAC6A}" dt="2026-03-06T06:16:08.810" v="7445" actId="27636"/>
+          <ac:spMkLst>
+            <pc:docMk/>
+            <pc:sldMk cId="3613664226" sldId="265"/>
+            <ac:spMk id="3" creationId="{3E951AF2-933E-B98D-E4FD-8FDEF142CC3C}"/>
+          </ac:spMkLst>
+        </pc:spChg>
+      </pc:sldChg>
+      <pc:sldChg chg="modSp new mod">
+        <pc:chgData name="musukie52@gmail.com" userId="017bd91f96aa8751" providerId="LiveId" clId="{5B2C3894-F97E-4CAB-8812-5BB4D83AAC6A}" dt="2026-03-06T06:26:05.480" v="8061" actId="20577"/>
+        <pc:sldMkLst>
+          <pc:docMk/>
+          <pc:sldMk cId="172995389" sldId="266"/>
+        </pc:sldMkLst>
+        <pc:spChg chg="mod">
+          <ac:chgData name="musukie52@gmail.com" userId="017bd91f96aa8751" providerId="LiveId" clId="{5B2C3894-F97E-4CAB-8812-5BB4D83AAC6A}" dt="2026-03-06T06:16:45.087" v="7507" actId="404"/>
+          <ac:spMkLst>
+            <pc:docMk/>
+            <pc:sldMk cId="172995389" sldId="266"/>
+            <ac:spMk id="2" creationId="{5727EB39-C367-0974-4015-7C899BCE803C}"/>
+          </ac:spMkLst>
+        </pc:spChg>
+        <pc:spChg chg="mod">
+          <ac:chgData name="musukie52@gmail.com" userId="017bd91f96aa8751" providerId="LiveId" clId="{5B2C3894-F97E-4CAB-8812-5BB4D83AAC6A}" dt="2026-03-06T06:26:05.480" v="8061" actId="20577"/>
+          <ac:spMkLst>
+            <pc:docMk/>
+            <pc:sldMk cId="172995389" sldId="266"/>
+            <ac:spMk id="3" creationId="{7C967B42-FB7B-7579-DF07-BF0E3F30BF41}"/>
+          </ac:spMkLst>
+        </pc:spChg>
       </pc:sldChg>
     </pc:docChg>
   </pc:docChgLst>
@@ -3370,7 +3631,22 @@
           <a:bodyPr/>
           <a:lstStyle/>
           <a:p>
-            <a:endParaRPr lang="ko-KR" altLang="en-US"/>
+            <a:r>
+              <a:rPr lang="ko-KR" altLang="en-US" dirty="0" err="1"/>
+              <a:t>유리같은</a:t>
+            </a:r>
+            <a:r>
+              <a:rPr lang="ko-KR" altLang="en-US" dirty="0"/>
+              <a:t> </a:t>
+            </a:r>
+            <a:r>
+              <a:rPr lang="en-US" altLang="ko-KR" dirty="0"/>
+              <a:t>Material</a:t>
+            </a:r>
+            <a:r>
+              <a:rPr lang="ko-KR" altLang="en-US" dirty="0"/>
+              <a:t> 만들기</a:t>
+            </a:r>
           </a:p>
         </p:txBody>
       </p:sp>
@@ -3390,12 +3666,360 @@
             <p:ph idx="1"/>
           </p:nvPr>
         </p:nvSpPr>
-        <p:spPr/>
+        <p:spPr>
+          <a:xfrm>
+            <a:off x="838200" y="1825625"/>
+            <a:ext cx="10515600" cy="1603375"/>
+          </a:xfrm>
+        </p:spPr>
         <p:txBody>
           <a:bodyPr/>
           <a:lstStyle/>
           <a:p>
-            <a:endParaRPr lang="ko-KR" altLang="en-US"/>
+            <a:r>
+              <a:rPr lang="en-US" altLang="ko-KR" dirty="0"/>
+              <a:t>Surface Inputs </a:t>
+            </a:r>
+            <a:r>
+              <a:rPr lang="ko-KR" altLang="en-US" dirty="0" err="1"/>
+              <a:t>인스펙터에서</a:t>
+            </a:r>
+            <a:r>
+              <a:rPr lang="ko-KR" altLang="en-US" dirty="0"/>
+              <a:t> </a:t>
+            </a:r>
+            <a:r>
+              <a:rPr lang="en-US" altLang="ko-KR" dirty="0" err="1"/>
+              <a:t>Emmission</a:t>
+            </a:r>
+            <a:r>
+              <a:rPr lang="ko-KR" altLang="en-US" dirty="0"/>
+              <a:t>을 활성화하고 거기서 </a:t>
+            </a:r>
+            <a:r>
+              <a:rPr lang="en-US" altLang="ko-KR" dirty="0"/>
+              <a:t>HDR Color</a:t>
+            </a:r>
+            <a:r>
+              <a:rPr lang="ko-KR" altLang="en-US" dirty="0"/>
+              <a:t>로 색을 설정하기</a:t>
+            </a:r>
+            <a:r>
+              <a:rPr lang="en-US" altLang="ko-KR" dirty="0"/>
+              <a:t>.</a:t>
+            </a:r>
+          </a:p>
+          <a:p>
+            <a:r>
+              <a:rPr lang="ko-KR" altLang="en-US" dirty="0"/>
+              <a:t>그러면 빛나는 </a:t>
+            </a:r>
+            <a:r>
+              <a:rPr lang="ko-KR" altLang="en-US" dirty="0" err="1"/>
+              <a:t>창문같은</a:t>
+            </a:r>
+            <a:r>
+              <a:rPr lang="ko-KR" altLang="en-US" dirty="0"/>
+              <a:t> </a:t>
+            </a:r>
+            <a:r>
+              <a:rPr lang="en-US" altLang="ko-KR" dirty="0"/>
+              <a:t>Material</a:t>
+            </a:r>
+            <a:r>
+              <a:rPr lang="ko-KR" altLang="en-US" dirty="0"/>
+              <a:t>을 만들 수 있다</a:t>
+            </a:r>
+            <a:r>
+              <a:rPr lang="en-US" altLang="ko-KR" dirty="0"/>
+              <a:t>.</a:t>
+            </a:r>
+            <a:endParaRPr lang="ko-KR" altLang="en-US" dirty="0"/>
+          </a:p>
+        </p:txBody>
+      </p:sp>
+      <p:sp>
+        <p:nvSpPr>
+          <p:cNvPr id="4" name="제목 1">
+            <a:extLst>
+              <a:ext uri="{FF2B5EF4-FFF2-40B4-BE49-F238E27FC236}">
+                <a16:creationId xmlns:a16="http://schemas.microsoft.com/office/drawing/2014/main" id="{FA52AAAC-0260-6B5F-96A4-13BCA931000D}"/>
+              </a:ext>
+            </a:extLst>
+          </p:cNvPr>
+          <p:cNvSpPr txBox="1">
+            <a:spLocks/>
+          </p:cNvSpPr>
+          <p:nvPr/>
+        </p:nvSpPr>
+        <p:spPr>
+          <a:xfrm>
+            <a:off x="838200" y="3557905"/>
+            <a:ext cx="10515600" cy="1325563"/>
+          </a:xfrm>
+          <a:prstGeom prst="rect">
+            <a:avLst/>
+          </a:prstGeom>
+        </p:spPr>
+        <p:txBody>
+          <a:bodyPr vert="horz" lIns="91440" tIns="45720" rIns="91440" bIns="45720" rtlCol="0" anchor="ctr">
+            <a:normAutofit/>
+          </a:bodyPr>
+          <a:lstStyle>
+            <a:lvl1pPr algn="l" defTabSz="914400" rtl="0" eaLnBrk="1" latinLnBrk="1" hangingPunct="1">
+              <a:lnSpc>
+                <a:spcPct val="90000"/>
+              </a:lnSpc>
+              <a:spcBef>
+                <a:spcPct val="0"/>
+              </a:spcBef>
+              <a:buNone/>
+              <a:defRPr sz="4400" kern="1200">
+                <a:solidFill>
+                  <a:schemeClr val="tx1"/>
+                </a:solidFill>
+                <a:latin typeface="+mj-lt"/>
+                <a:ea typeface="+mj-ea"/>
+                <a:cs typeface="+mj-cs"/>
+              </a:defRPr>
+            </a:lvl1pPr>
+          </a:lstStyle>
+          <a:p>
+            <a:r>
+              <a:rPr lang="en-US" altLang="ko-KR" dirty="0"/>
+              <a:t>Auto Save</a:t>
+            </a:r>
+            <a:endParaRPr lang="ko-KR" altLang="en-US" dirty="0"/>
+          </a:p>
+        </p:txBody>
+      </p:sp>
+      <p:sp>
+        <p:nvSpPr>
+          <p:cNvPr id="5" name="내용 개체 틀 2">
+            <a:extLst>
+              <a:ext uri="{FF2B5EF4-FFF2-40B4-BE49-F238E27FC236}">
+                <a16:creationId xmlns:a16="http://schemas.microsoft.com/office/drawing/2014/main" id="{81B607D6-3AAF-6960-9D9F-D0CA6F0577B6}"/>
+              </a:ext>
+            </a:extLst>
+          </p:cNvPr>
+          <p:cNvSpPr txBox="1">
+            <a:spLocks/>
+          </p:cNvSpPr>
+          <p:nvPr/>
+        </p:nvSpPr>
+        <p:spPr>
+          <a:xfrm>
+            <a:off x="838200" y="4709795"/>
+            <a:ext cx="10515600" cy="1603375"/>
+          </a:xfrm>
+          <a:prstGeom prst="rect">
+            <a:avLst/>
+          </a:prstGeom>
+        </p:spPr>
+        <p:txBody>
+          <a:bodyPr vert="horz" lIns="91440" tIns="45720" rIns="91440" bIns="45720" rtlCol="0">
+            <a:normAutofit/>
+          </a:bodyPr>
+          <a:lstStyle>
+            <a:lvl1pPr marL="228600" indent="-228600" algn="l" defTabSz="914400" rtl="0" eaLnBrk="1" latinLnBrk="1" hangingPunct="1">
+              <a:lnSpc>
+                <a:spcPct val="90000"/>
+              </a:lnSpc>
+              <a:spcBef>
+                <a:spcPts val="1000"/>
+              </a:spcBef>
+              <a:buFont typeface="Arial" panose="020B0604020202020204" pitchFamily="34" charset="0"/>
+              <a:buChar char="•"/>
+              <a:defRPr sz="2800" kern="1200">
+                <a:solidFill>
+                  <a:schemeClr val="tx1"/>
+                </a:solidFill>
+                <a:latin typeface="+mn-lt"/>
+                <a:ea typeface="+mn-ea"/>
+                <a:cs typeface="+mn-cs"/>
+              </a:defRPr>
+            </a:lvl1pPr>
+            <a:lvl2pPr marL="685800" indent="-228600" algn="l" defTabSz="914400" rtl="0" eaLnBrk="1" latinLnBrk="1" hangingPunct="1">
+              <a:lnSpc>
+                <a:spcPct val="90000"/>
+              </a:lnSpc>
+              <a:spcBef>
+                <a:spcPts val="500"/>
+              </a:spcBef>
+              <a:buFont typeface="Arial" panose="020B0604020202020204" pitchFamily="34" charset="0"/>
+              <a:buChar char="•"/>
+              <a:defRPr sz="2400" kern="1200">
+                <a:solidFill>
+                  <a:schemeClr val="tx1"/>
+                </a:solidFill>
+                <a:latin typeface="+mn-lt"/>
+                <a:ea typeface="+mn-ea"/>
+                <a:cs typeface="+mn-cs"/>
+              </a:defRPr>
+            </a:lvl2pPr>
+            <a:lvl3pPr marL="1143000" indent="-228600" algn="l" defTabSz="914400" rtl="0" eaLnBrk="1" latinLnBrk="1" hangingPunct="1">
+              <a:lnSpc>
+                <a:spcPct val="90000"/>
+              </a:lnSpc>
+              <a:spcBef>
+                <a:spcPts val="500"/>
+              </a:spcBef>
+              <a:buFont typeface="Arial" panose="020B0604020202020204" pitchFamily="34" charset="0"/>
+              <a:buChar char="•"/>
+              <a:defRPr sz="2000" kern="1200">
+                <a:solidFill>
+                  <a:schemeClr val="tx1"/>
+                </a:solidFill>
+                <a:latin typeface="+mn-lt"/>
+                <a:ea typeface="+mn-ea"/>
+                <a:cs typeface="+mn-cs"/>
+              </a:defRPr>
+            </a:lvl3pPr>
+            <a:lvl4pPr marL="1600200" indent="-228600" algn="l" defTabSz="914400" rtl="0" eaLnBrk="1" latinLnBrk="1" hangingPunct="1">
+              <a:lnSpc>
+                <a:spcPct val="90000"/>
+              </a:lnSpc>
+              <a:spcBef>
+                <a:spcPts val="500"/>
+              </a:spcBef>
+              <a:buFont typeface="Arial" panose="020B0604020202020204" pitchFamily="34" charset="0"/>
+              <a:buChar char="•"/>
+              <a:defRPr sz="1800" kern="1200">
+                <a:solidFill>
+                  <a:schemeClr val="tx1"/>
+                </a:solidFill>
+                <a:latin typeface="+mn-lt"/>
+                <a:ea typeface="+mn-ea"/>
+                <a:cs typeface="+mn-cs"/>
+              </a:defRPr>
+            </a:lvl4pPr>
+            <a:lvl5pPr marL="2057400" indent="-228600" algn="l" defTabSz="914400" rtl="0" eaLnBrk="1" latinLnBrk="1" hangingPunct="1">
+              <a:lnSpc>
+                <a:spcPct val="90000"/>
+              </a:lnSpc>
+              <a:spcBef>
+                <a:spcPts val="500"/>
+              </a:spcBef>
+              <a:buFont typeface="Arial" panose="020B0604020202020204" pitchFamily="34" charset="0"/>
+              <a:buChar char="•"/>
+              <a:defRPr sz="1800" kern="1200">
+                <a:solidFill>
+                  <a:schemeClr val="tx1"/>
+                </a:solidFill>
+                <a:latin typeface="+mn-lt"/>
+                <a:ea typeface="+mn-ea"/>
+                <a:cs typeface="+mn-cs"/>
+              </a:defRPr>
+            </a:lvl5pPr>
+            <a:lvl6pPr marL="2514600" indent="-228600" algn="l" defTabSz="914400" rtl="0" eaLnBrk="1" latinLnBrk="1" hangingPunct="1">
+              <a:lnSpc>
+                <a:spcPct val="90000"/>
+              </a:lnSpc>
+              <a:spcBef>
+                <a:spcPts val="500"/>
+              </a:spcBef>
+              <a:buFont typeface="Arial" panose="020B0604020202020204" pitchFamily="34" charset="0"/>
+              <a:buChar char="•"/>
+              <a:defRPr sz="1800" kern="1200">
+                <a:solidFill>
+                  <a:schemeClr val="tx1"/>
+                </a:solidFill>
+                <a:latin typeface="+mn-lt"/>
+                <a:ea typeface="+mn-ea"/>
+                <a:cs typeface="+mn-cs"/>
+              </a:defRPr>
+            </a:lvl6pPr>
+            <a:lvl7pPr marL="2971800" indent="-228600" algn="l" defTabSz="914400" rtl="0" eaLnBrk="1" latinLnBrk="1" hangingPunct="1">
+              <a:lnSpc>
+                <a:spcPct val="90000"/>
+              </a:lnSpc>
+              <a:spcBef>
+                <a:spcPts val="500"/>
+              </a:spcBef>
+              <a:buFont typeface="Arial" panose="020B0604020202020204" pitchFamily="34" charset="0"/>
+              <a:buChar char="•"/>
+              <a:defRPr sz="1800" kern="1200">
+                <a:solidFill>
+                  <a:schemeClr val="tx1"/>
+                </a:solidFill>
+                <a:latin typeface="+mn-lt"/>
+                <a:ea typeface="+mn-ea"/>
+                <a:cs typeface="+mn-cs"/>
+              </a:defRPr>
+            </a:lvl7pPr>
+            <a:lvl8pPr marL="3429000" indent="-228600" algn="l" defTabSz="914400" rtl="0" eaLnBrk="1" latinLnBrk="1" hangingPunct="1">
+              <a:lnSpc>
+                <a:spcPct val="90000"/>
+              </a:lnSpc>
+              <a:spcBef>
+                <a:spcPts val="500"/>
+              </a:spcBef>
+              <a:buFont typeface="Arial" panose="020B0604020202020204" pitchFamily="34" charset="0"/>
+              <a:buChar char="•"/>
+              <a:defRPr sz="1800" kern="1200">
+                <a:solidFill>
+                  <a:schemeClr val="tx1"/>
+                </a:solidFill>
+                <a:latin typeface="+mn-lt"/>
+                <a:ea typeface="+mn-ea"/>
+                <a:cs typeface="+mn-cs"/>
+              </a:defRPr>
+            </a:lvl8pPr>
+            <a:lvl9pPr marL="3886200" indent="-228600" algn="l" defTabSz="914400" rtl="0" eaLnBrk="1" latinLnBrk="1" hangingPunct="1">
+              <a:lnSpc>
+                <a:spcPct val="90000"/>
+              </a:lnSpc>
+              <a:spcBef>
+                <a:spcPts val="500"/>
+              </a:spcBef>
+              <a:buFont typeface="Arial" panose="020B0604020202020204" pitchFamily="34" charset="0"/>
+              <a:buChar char="•"/>
+              <a:defRPr sz="1800" kern="1200">
+                <a:solidFill>
+                  <a:schemeClr val="tx1"/>
+                </a:solidFill>
+                <a:latin typeface="+mn-lt"/>
+                <a:ea typeface="+mn-ea"/>
+                <a:cs typeface="+mn-cs"/>
+              </a:defRPr>
+            </a:lvl9pPr>
+          </a:lstStyle>
+          <a:p>
+            <a:r>
+              <a:rPr lang="ko-KR" altLang="en-US" dirty="0"/>
+              <a:t>프로젝트 규모가 커지면 매 순간 저장을 시도하므로 </a:t>
+            </a:r>
+            <a:r>
+              <a:rPr lang="ko-KR" altLang="en-US" dirty="0" err="1"/>
+              <a:t>렉이</a:t>
+            </a:r>
+            <a:r>
+              <a:rPr lang="ko-KR" altLang="en-US" dirty="0"/>
+              <a:t> 걸릴 수 있다</a:t>
+            </a:r>
+            <a:r>
+              <a:rPr lang="en-US" altLang="ko-KR" dirty="0"/>
+              <a:t>.</a:t>
+            </a:r>
+          </a:p>
+          <a:p>
+            <a:r>
+              <a:rPr lang="ko-KR" altLang="en-US" dirty="0"/>
+              <a:t>따라서 </a:t>
+            </a:r>
+            <a:r>
+              <a:rPr lang="en-US" altLang="ko-KR" dirty="0"/>
+              <a:t>Auto Save</a:t>
+            </a:r>
+            <a:r>
+              <a:rPr lang="ko-KR" altLang="en-US" dirty="0"/>
+              <a:t>를 끄고 수동으로 저장하는 습관을 기르자</a:t>
+            </a:r>
+            <a:r>
+              <a:rPr lang="en-US" altLang="ko-KR" dirty="0"/>
+              <a:t>.</a:t>
+            </a:r>
+            <a:endParaRPr lang="ko-KR" altLang="en-US" dirty="0"/>
           </a:p>
         </p:txBody>
       </p:sp>
@@ -3403,6 +4027,2372 @@
     <p:extLst>
       <p:ext uri="{BB962C8B-B14F-4D97-AF65-F5344CB8AC3E}">
         <p14:creationId xmlns:p14="http://schemas.microsoft.com/office/powerpoint/2010/main" val="850242358"/>
+      </p:ext>
+    </p:extLst>
+  </p:cSld>
+  <p:clrMapOvr>
+    <a:masterClrMapping/>
+  </p:clrMapOvr>
+</p:sld>
+</file>
+
+<file path=ppt/slides/slide10.xml><?xml version="1.0" encoding="utf-8"?>
+<p:sld xmlns:a="http://schemas.openxmlformats.org/drawingml/2006/main" xmlns:r="http://schemas.openxmlformats.org/officeDocument/2006/relationships" xmlns:p="http://schemas.openxmlformats.org/presentationml/2006/main">
+  <p:cSld>
+    <p:spTree>
+      <p:nvGrpSpPr>
+        <p:cNvPr id="1" name=""/>
+        <p:cNvGrpSpPr/>
+        <p:nvPr/>
+      </p:nvGrpSpPr>
+      <p:grpSpPr>
+        <a:xfrm>
+          <a:off x="0" y="0"/>
+          <a:ext cx="0" cy="0"/>
+          <a:chOff x="0" y="0"/>
+          <a:chExt cx="0" cy="0"/>
+        </a:xfrm>
+      </p:grpSpPr>
+      <p:sp>
+        <p:nvSpPr>
+          <p:cNvPr id="2" name="제목 1">
+            <a:extLst>
+              <a:ext uri="{FF2B5EF4-FFF2-40B4-BE49-F238E27FC236}">
+                <a16:creationId xmlns:a16="http://schemas.microsoft.com/office/drawing/2014/main" id="{5727EB39-C367-0974-4015-7C899BCE803C}"/>
+              </a:ext>
+            </a:extLst>
+          </p:cNvPr>
+          <p:cNvSpPr>
+            <a:spLocks noGrp="1"/>
+          </p:cNvSpPr>
+          <p:nvPr>
+            <p:ph type="title"/>
+          </p:nvPr>
+        </p:nvSpPr>
+        <p:spPr/>
+        <p:txBody>
+          <a:bodyPr>
+            <a:normAutofit/>
+          </a:bodyPr>
+          <a:lstStyle/>
+          <a:p>
+            <a:r>
+              <a:rPr lang="ko-KR" altLang="en-US" sz="3600" dirty="0"/>
+              <a:t>외부에서 </a:t>
+            </a:r>
+            <a:r>
+              <a:rPr lang="ko-KR" altLang="en-US" sz="3600" dirty="0" err="1"/>
+              <a:t>에셋을</a:t>
+            </a:r>
+            <a:r>
+              <a:rPr lang="ko-KR" altLang="en-US" sz="3600" dirty="0"/>
+              <a:t> 사서 </a:t>
+            </a:r>
+            <a:r>
+              <a:rPr lang="en-US" altLang="ko-KR" sz="3600" dirty="0"/>
+              <a:t>Scene</a:t>
+            </a:r>
+            <a:r>
+              <a:rPr lang="ko-KR" altLang="en-US" sz="3600" dirty="0"/>
+              <a:t>에 배치하는 방법</a:t>
+            </a:r>
+          </a:p>
+        </p:txBody>
+      </p:sp>
+      <p:sp>
+        <p:nvSpPr>
+          <p:cNvPr id="3" name="내용 개체 틀 2">
+            <a:extLst>
+              <a:ext uri="{FF2B5EF4-FFF2-40B4-BE49-F238E27FC236}">
+                <a16:creationId xmlns:a16="http://schemas.microsoft.com/office/drawing/2014/main" id="{7C967B42-FB7B-7579-DF07-BF0E3F30BF41}"/>
+              </a:ext>
+            </a:extLst>
+          </p:cNvPr>
+          <p:cNvSpPr>
+            <a:spLocks noGrp="1"/>
+          </p:cNvSpPr>
+          <p:nvPr>
+            <p:ph idx="1"/>
+          </p:nvPr>
+        </p:nvSpPr>
+        <p:spPr>
+          <a:xfrm>
+            <a:off x="750570" y="1825625"/>
+            <a:ext cx="10690860" cy="4351338"/>
+          </a:xfrm>
+        </p:spPr>
+        <p:txBody>
+          <a:bodyPr/>
+          <a:lstStyle/>
+          <a:p>
+            <a:r>
+              <a:rPr lang="en-US" altLang="ko-KR" dirty="0"/>
+              <a:t>Asset Store </a:t>
+            </a:r>
+            <a:r>
+              <a:rPr lang="ko-KR" altLang="en-US" dirty="0"/>
+              <a:t>사이트에 접속해서 원하는 </a:t>
+            </a:r>
+            <a:r>
+              <a:rPr lang="ko-KR" altLang="en-US" dirty="0" err="1"/>
+              <a:t>에셋</a:t>
+            </a:r>
+            <a:r>
+              <a:rPr lang="en-US" altLang="ko-KR" dirty="0"/>
+              <a:t>(</a:t>
+            </a:r>
+            <a:r>
+              <a:rPr lang="ko-KR" altLang="en-US" dirty="0"/>
+              <a:t>무료도 있음</a:t>
+            </a:r>
+            <a:r>
+              <a:rPr lang="en-US" altLang="ko-KR" dirty="0"/>
+              <a:t>)</a:t>
+            </a:r>
+            <a:r>
+              <a:rPr lang="ko-KR" altLang="en-US" dirty="0"/>
+              <a:t>을 구매</a:t>
+            </a:r>
+            <a:endParaRPr lang="en-US" altLang="ko-KR" dirty="0"/>
+          </a:p>
+          <a:p>
+            <a:r>
+              <a:rPr lang="ko-KR" altLang="en-US" dirty="0"/>
+              <a:t>다운로드 해서 </a:t>
+            </a:r>
+            <a:r>
+              <a:rPr lang="en-US" altLang="ko-KR" dirty="0"/>
+              <a:t>Import</a:t>
+            </a:r>
+            <a:r>
+              <a:rPr lang="ko-KR" altLang="en-US" dirty="0"/>
+              <a:t>하면 내 작업에 적용 가능하게 된다</a:t>
+            </a:r>
+            <a:r>
+              <a:rPr lang="en-US" altLang="ko-KR" dirty="0"/>
+              <a:t>.</a:t>
+            </a:r>
+          </a:p>
+          <a:p>
+            <a:endParaRPr lang="en-US" altLang="ko-KR" dirty="0"/>
+          </a:p>
+          <a:p>
+            <a:r>
+              <a:rPr lang="en-US" altLang="ko-KR" dirty="0"/>
+              <a:t>Material</a:t>
+            </a:r>
+            <a:r>
+              <a:rPr lang="ko-KR" altLang="en-US" dirty="0"/>
+              <a:t>이 바로 적용되지 않는 경우</a:t>
+            </a:r>
+            <a:endParaRPr lang="en-US" altLang="ko-KR" dirty="0"/>
+          </a:p>
+          <a:p>
+            <a:pPr lvl="1"/>
+            <a:r>
+              <a:rPr lang="en-US" altLang="ko-KR" dirty="0"/>
+              <a:t>-&gt; </a:t>
+            </a:r>
+            <a:r>
+              <a:rPr lang="ko-KR" altLang="en-US" dirty="0"/>
+              <a:t>모든 </a:t>
+            </a:r>
+            <a:r>
+              <a:rPr lang="en-US" altLang="ko-KR" dirty="0"/>
+              <a:t>Material</a:t>
+            </a:r>
+            <a:r>
+              <a:rPr lang="ko-KR" altLang="en-US" dirty="0"/>
+              <a:t>을 선택 후 </a:t>
+            </a:r>
+            <a:r>
+              <a:rPr lang="en-US" altLang="ko-KR" dirty="0"/>
+              <a:t>-&gt; </a:t>
+            </a:r>
+            <a:r>
+              <a:rPr lang="ko-KR" altLang="en-US" dirty="0"/>
+              <a:t>상단 </a:t>
+            </a:r>
+            <a:r>
+              <a:rPr lang="en-US" altLang="ko-KR" dirty="0"/>
+              <a:t>Edit </a:t>
+            </a:r>
+            <a:r>
+              <a:rPr lang="ko-KR" altLang="en-US" dirty="0"/>
+              <a:t>클릭 </a:t>
+            </a:r>
+            <a:r>
+              <a:rPr lang="en-US" altLang="ko-KR" dirty="0"/>
+              <a:t>-&gt; </a:t>
+            </a:r>
+            <a:r>
+              <a:rPr lang="ko-KR" altLang="en-US" dirty="0"/>
+              <a:t>아래쪽의 </a:t>
+            </a:r>
+            <a:r>
+              <a:rPr lang="en-US" altLang="ko-KR" dirty="0"/>
+              <a:t>‘Rendering’ </a:t>
+            </a:r>
+            <a:r>
+              <a:rPr lang="ko-KR" altLang="en-US" dirty="0"/>
+              <a:t>클릭 </a:t>
+            </a:r>
+            <a:r>
+              <a:rPr lang="en-US" altLang="ko-KR" dirty="0"/>
+              <a:t>-&gt; Materials -&gt; Convert Selected Built-in Materials to URP </a:t>
+            </a:r>
+            <a:r>
+              <a:rPr lang="ko-KR" altLang="en-US" dirty="0"/>
+              <a:t>클릭 </a:t>
+            </a:r>
+            <a:r>
+              <a:rPr lang="en-US" altLang="ko-KR" dirty="0"/>
+              <a:t>-&gt; Proceed </a:t>
+            </a:r>
+            <a:r>
+              <a:rPr lang="ko-KR" altLang="en-US" dirty="0"/>
+              <a:t>하면 </a:t>
+            </a:r>
+            <a:r>
+              <a:rPr lang="en-US" altLang="ko-KR" dirty="0"/>
+              <a:t>Material</a:t>
+            </a:r>
+            <a:r>
+              <a:rPr lang="ko-KR" altLang="en-US" dirty="0"/>
+              <a:t>이 모두 적용된다</a:t>
+            </a:r>
+            <a:r>
+              <a:rPr lang="en-US" altLang="ko-KR" dirty="0"/>
+              <a:t>. </a:t>
+            </a:r>
+            <a:r>
+              <a:rPr lang="ko-KR" altLang="en-US" dirty="0"/>
+              <a:t>그래도 적용이 안 된다면 저장</a:t>
+            </a:r>
+            <a:r>
+              <a:rPr lang="en-US" altLang="ko-KR" dirty="0"/>
+              <a:t>(Ctrl + S)</a:t>
+            </a:r>
+            <a:r>
+              <a:rPr lang="ko-KR" altLang="en-US" dirty="0"/>
+              <a:t>하면 적용된다</a:t>
+            </a:r>
+            <a:r>
+              <a:rPr lang="en-US" altLang="ko-KR" dirty="0"/>
+              <a:t>.</a:t>
+            </a:r>
+          </a:p>
+          <a:p>
+            <a:endParaRPr lang="ko-KR" altLang="en-US" dirty="0"/>
+          </a:p>
+        </p:txBody>
+      </p:sp>
+    </p:spTree>
+    <p:extLst>
+      <p:ext uri="{BB962C8B-B14F-4D97-AF65-F5344CB8AC3E}">
+        <p14:creationId xmlns:p14="http://schemas.microsoft.com/office/powerpoint/2010/main" val="172995389"/>
+      </p:ext>
+    </p:extLst>
+  </p:cSld>
+  <p:clrMapOvr>
+    <a:masterClrMapping/>
+  </p:clrMapOvr>
+</p:sld>
+</file>
+
+<file path=ppt/slides/slide2.xml><?xml version="1.0" encoding="utf-8"?>
+<p:sld xmlns:a="http://schemas.openxmlformats.org/drawingml/2006/main" xmlns:r="http://schemas.openxmlformats.org/officeDocument/2006/relationships" xmlns:p="http://schemas.openxmlformats.org/presentationml/2006/main">
+  <p:cSld>
+    <p:spTree>
+      <p:nvGrpSpPr>
+        <p:cNvPr id="1" name=""/>
+        <p:cNvGrpSpPr/>
+        <p:nvPr/>
+      </p:nvGrpSpPr>
+      <p:grpSpPr>
+        <a:xfrm>
+          <a:off x="0" y="0"/>
+          <a:ext cx="0" cy="0"/>
+          <a:chOff x="0" y="0"/>
+          <a:chExt cx="0" cy="0"/>
+        </a:xfrm>
+      </p:grpSpPr>
+      <p:sp>
+        <p:nvSpPr>
+          <p:cNvPr id="2" name="제목 1">
+            <a:extLst>
+              <a:ext uri="{FF2B5EF4-FFF2-40B4-BE49-F238E27FC236}">
+                <a16:creationId xmlns:a16="http://schemas.microsoft.com/office/drawing/2014/main" id="{3A0DD556-6D1F-B217-6D4E-0E3106444940}"/>
+              </a:ext>
+            </a:extLst>
+          </p:cNvPr>
+          <p:cNvSpPr>
+            <a:spLocks noGrp="1"/>
+          </p:cNvSpPr>
+          <p:nvPr>
+            <p:ph type="title"/>
+          </p:nvPr>
+        </p:nvSpPr>
+        <p:spPr/>
+        <p:txBody>
+          <a:bodyPr/>
+          <a:lstStyle/>
+          <a:p>
+            <a:r>
+              <a:rPr lang="ko-KR" altLang="en-US" dirty="0"/>
+              <a:t>오브젝트 </a:t>
+            </a:r>
+            <a:r>
+              <a:rPr lang="ko-KR" altLang="en-US" dirty="0" err="1"/>
+              <a:t>우클릭</a:t>
+            </a:r>
+            <a:r>
+              <a:rPr lang="ko-KR" altLang="en-US" dirty="0"/>
+              <a:t> </a:t>
+            </a:r>
+            <a:r>
+              <a:rPr lang="en-US" altLang="ko-KR" dirty="0"/>
+              <a:t>-&gt; Light</a:t>
+            </a:r>
+            <a:endParaRPr lang="ko-KR" altLang="en-US" dirty="0"/>
+          </a:p>
+        </p:txBody>
+      </p:sp>
+      <p:sp>
+        <p:nvSpPr>
+          <p:cNvPr id="3" name="내용 개체 틀 2">
+            <a:extLst>
+              <a:ext uri="{FF2B5EF4-FFF2-40B4-BE49-F238E27FC236}">
+                <a16:creationId xmlns:a16="http://schemas.microsoft.com/office/drawing/2014/main" id="{37DFC9F1-F6D2-9916-8C6E-8B0A5AD6BB7A}"/>
+              </a:ext>
+            </a:extLst>
+          </p:cNvPr>
+          <p:cNvSpPr>
+            <a:spLocks noGrp="1"/>
+          </p:cNvSpPr>
+          <p:nvPr>
+            <p:ph idx="1"/>
+          </p:nvPr>
+        </p:nvSpPr>
+        <p:spPr/>
+        <p:txBody>
+          <a:bodyPr>
+            <a:normAutofit/>
+          </a:bodyPr>
+          <a:lstStyle/>
+          <a:p>
+            <a:r>
+              <a:rPr lang="en-US" altLang="ko-KR" dirty="0"/>
+              <a:t>Hierarchy</a:t>
+            </a:r>
+            <a:r>
+              <a:rPr lang="ko-KR" altLang="en-US" dirty="0"/>
+              <a:t>에서 </a:t>
+            </a:r>
+            <a:r>
+              <a:rPr lang="en-US" altLang="ko-KR" dirty="0"/>
+              <a:t>Directional Light</a:t>
+            </a:r>
+            <a:r>
+              <a:rPr lang="ko-KR" altLang="en-US" dirty="0"/>
+              <a:t>를 찾을 수 있다</a:t>
+            </a:r>
+            <a:r>
+              <a:rPr lang="en-US" altLang="ko-KR" dirty="0"/>
+              <a:t>.</a:t>
+            </a:r>
+          </a:p>
+          <a:p>
+            <a:r>
+              <a:rPr lang="ko-KR" altLang="en-US" dirty="0" err="1"/>
+              <a:t>인스펙터에서</a:t>
+            </a:r>
+            <a:r>
+              <a:rPr lang="ko-KR" altLang="en-US" dirty="0"/>
+              <a:t> </a:t>
+            </a:r>
+            <a:r>
+              <a:rPr lang="en-US" altLang="ko-KR" dirty="0"/>
+              <a:t>Light </a:t>
+            </a:r>
+            <a:r>
+              <a:rPr lang="ko-KR" altLang="en-US" dirty="0"/>
+              <a:t>항목을 찾을 수도 있다</a:t>
+            </a:r>
+            <a:r>
+              <a:rPr lang="en-US" altLang="ko-KR" dirty="0"/>
+              <a:t>.</a:t>
+            </a:r>
+          </a:p>
+          <a:p>
+            <a:pPr lvl="1"/>
+            <a:r>
+              <a:rPr lang="en-US" altLang="ko-KR" dirty="0"/>
+              <a:t>Type : Directional, Spot, Point, Area</a:t>
+            </a:r>
+          </a:p>
+          <a:p>
+            <a:pPr lvl="1"/>
+            <a:r>
+              <a:rPr lang="en-US" altLang="ko-KR" dirty="0"/>
+              <a:t>Mode : Realtime(</a:t>
+            </a:r>
+            <a:r>
+              <a:rPr lang="ko-KR" altLang="en-US" dirty="0"/>
+              <a:t>실시간</a:t>
+            </a:r>
+            <a:r>
+              <a:rPr lang="en-US" altLang="ko-KR" dirty="0"/>
+              <a:t>. </a:t>
+            </a:r>
+            <a:r>
+              <a:rPr lang="ko-KR" altLang="en-US" dirty="0"/>
+              <a:t>프로젝트 규모가 커지면 이걸 쓰면 </a:t>
+            </a:r>
+            <a:r>
+              <a:rPr lang="ko-KR" altLang="en-US" dirty="0" err="1"/>
+              <a:t>렉이</a:t>
+            </a:r>
+            <a:r>
+              <a:rPr lang="ko-KR" altLang="en-US" dirty="0"/>
+              <a:t> 많이 걸린다</a:t>
+            </a:r>
+            <a:r>
+              <a:rPr lang="en-US" altLang="ko-KR" dirty="0"/>
+              <a:t>.), Baked(</a:t>
+            </a:r>
+            <a:r>
+              <a:rPr lang="ko-KR" altLang="en-US" dirty="0"/>
+              <a:t>빛을 하나로 정해놓는다</a:t>
+            </a:r>
+            <a:r>
+              <a:rPr lang="en-US" altLang="ko-KR" dirty="0"/>
+              <a:t>. </a:t>
+            </a:r>
+            <a:r>
+              <a:rPr lang="ko-KR" altLang="en-US" dirty="0"/>
+              <a:t>작업할 때 이렇게 두고 작업하면 좋다</a:t>
+            </a:r>
+            <a:r>
+              <a:rPr lang="en-US" altLang="ko-KR" dirty="0"/>
+              <a:t>.), Mixed(Realtime + Baked)</a:t>
+            </a:r>
+          </a:p>
+          <a:p>
+            <a:pPr lvl="1"/>
+            <a:r>
+              <a:rPr lang="en-US" altLang="ko-KR" dirty="0"/>
+              <a:t>Color</a:t>
+            </a:r>
+            <a:r>
+              <a:rPr lang="ko-KR" altLang="en-US" dirty="0"/>
+              <a:t> </a:t>
+            </a:r>
+            <a:r>
+              <a:rPr lang="en-US" altLang="ko-KR" dirty="0"/>
+              <a:t>:</a:t>
+            </a:r>
+            <a:r>
+              <a:rPr lang="ko-KR" altLang="en-US" dirty="0"/>
+              <a:t> 빛의 색상</a:t>
+            </a:r>
+            <a:endParaRPr lang="en-US" altLang="ko-KR" dirty="0"/>
+          </a:p>
+          <a:p>
+            <a:pPr lvl="1"/>
+            <a:r>
+              <a:rPr lang="en-US" altLang="ko-KR" dirty="0"/>
+              <a:t>Intensity : </a:t>
+            </a:r>
+            <a:r>
+              <a:rPr lang="ko-KR" altLang="en-US" dirty="0"/>
+              <a:t>빛의 밝기 조절</a:t>
+            </a:r>
+            <a:r>
+              <a:rPr lang="en-US" altLang="ko-KR" dirty="0"/>
+              <a:t>.</a:t>
+            </a:r>
+          </a:p>
+          <a:p>
+            <a:pPr lvl="1"/>
+            <a:r>
+              <a:rPr lang="en-US" altLang="ko-KR" dirty="0"/>
+              <a:t>Indirect Multiplier : Baked</a:t>
+            </a:r>
+            <a:r>
+              <a:rPr lang="ko-KR" altLang="en-US" dirty="0"/>
+              <a:t>일 때만 사용 가능</a:t>
+            </a:r>
+            <a:r>
+              <a:rPr lang="en-US" altLang="ko-KR" dirty="0"/>
+              <a:t>. But Baked</a:t>
+            </a:r>
+            <a:r>
+              <a:rPr lang="ko-KR" altLang="en-US" dirty="0"/>
+              <a:t>를 사용하기 위해서 </a:t>
+            </a:r>
+            <a:r>
+              <a:rPr lang="en-US" altLang="ko-KR" dirty="0"/>
+              <a:t>Light</a:t>
+            </a:r>
+            <a:r>
+              <a:rPr lang="ko-KR" altLang="en-US" dirty="0"/>
+              <a:t> </a:t>
+            </a:r>
+            <a:r>
+              <a:rPr lang="en-US" altLang="ko-KR" dirty="0"/>
+              <a:t>Map</a:t>
+            </a:r>
+            <a:r>
+              <a:rPr lang="ko-KR" altLang="en-US" dirty="0"/>
+              <a:t>이 있어야 이 효과가 적용됨</a:t>
+            </a:r>
+            <a:r>
+              <a:rPr lang="en-US" altLang="ko-KR" dirty="0"/>
+              <a:t>.</a:t>
+            </a:r>
+          </a:p>
+          <a:p>
+            <a:endParaRPr lang="ko-KR" altLang="en-US" dirty="0"/>
+          </a:p>
+        </p:txBody>
+      </p:sp>
+    </p:spTree>
+    <p:extLst>
+      <p:ext uri="{BB962C8B-B14F-4D97-AF65-F5344CB8AC3E}">
+        <p14:creationId xmlns:p14="http://schemas.microsoft.com/office/powerpoint/2010/main" val="2981630723"/>
+      </p:ext>
+    </p:extLst>
+  </p:cSld>
+  <p:clrMapOvr>
+    <a:masterClrMapping/>
+  </p:clrMapOvr>
+</p:sld>
+</file>
+
+<file path=ppt/slides/slide3.xml><?xml version="1.0" encoding="utf-8"?>
+<p:sld xmlns:a="http://schemas.openxmlformats.org/drawingml/2006/main" xmlns:r="http://schemas.openxmlformats.org/officeDocument/2006/relationships" xmlns:p="http://schemas.openxmlformats.org/presentationml/2006/main">
+  <p:cSld>
+    <p:spTree>
+      <p:nvGrpSpPr>
+        <p:cNvPr id="1" name=""/>
+        <p:cNvGrpSpPr/>
+        <p:nvPr/>
+      </p:nvGrpSpPr>
+      <p:grpSpPr>
+        <a:xfrm>
+          <a:off x="0" y="0"/>
+          <a:ext cx="0" cy="0"/>
+          <a:chOff x="0" y="0"/>
+          <a:chExt cx="0" cy="0"/>
+        </a:xfrm>
+      </p:grpSpPr>
+      <p:sp>
+        <p:nvSpPr>
+          <p:cNvPr id="2" name="제목 1">
+            <a:extLst>
+              <a:ext uri="{FF2B5EF4-FFF2-40B4-BE49-F238E27FC236}">
+                <a16:creationId xmlns:a16="http://schemas.microsoft.com/office/drawing/2014/main" id="{8EF094E1-7868-478D-30C0-7760572E1A73}"/>
+              </a:ext>
+            </a:extLst>
+          </p:cNvPr>
+          <p:cNvSpPr>
+            <a:spLocks noGrp="1"/>
+          </p:cNvSpPr>
+          <p:nvPr>
+            <p:ph type="title"/>
+          </p:nvPr>
+        </p:nvSpPr>
+        <p:spPr/>
+        <p:txBody>
+          <a:bodyPr/>
+          <a:lstStyle/>
+          <a:p>
+            <a:r>
+              <a:rPr lang="en-US" altLang="ko-KR" dirty="0"/>
+              <a:t>Light</a:t>
+            </a:r>
+            <a:endParaRPr lang="ko-KR" altLang="en-US" dirty="0"/>
+          </a:p>
+        </p:txBody>
+      </p:sp>
+      <p:sp>
+        <p:nvSpPr>
+          <p:cNvPr id="3" name="내용 개체 틀 2">
+            <a:extLst>
+              <a:ext uri="{FF2B5EF4-FFF2-40B4-BE49-F238E27FC236}">
+                <a16:creationId xmlns:a16="http://schemas.microsoft.com/office/drawing/2014/main" id="{CBE2A73A-37CB-05FF-D329-490AADDD59F4}"/>
+              </a:ext>
+            </a:extLst>
+          </p:cNvPr>
+          <p:cNvSpPr>
+            <a:spLocks noGrp="1"/>
+          </p:cNvSpPr>
+          <p:nvPr>
+            <p:ph idx="1"/>
+          </p:nvPr>
+        </p:nvSpPr>
+        <p:spPr/>
+        <p:txBody>
+          <a:bodyPr/>
+          <a:lstStyle/>
+          <a:p>
+            <a:r>
+              <a:rPr lang="en-US" altLang="ko-KR" dirty="0"/>
+              <a:t>Directional Light : </a:t>
+            </a:r>
+            <a:r>
+              <a:rPr lang="ko-KR" altLang="en-US" dirty="0"/>
+              <a:t>태양 광</a:t>
+            </a:r>
+            <a:r>
+              <a:rPr lang="en-US" altLang="ko-KR" dirty="0"/>
+              <a:t>. </a:t>
+            </a:r>
+            <a:r>
+              <a:rPr lang="ko-KR" altLang="en-US" dirty="0"/>
+              <a:t>태양의 위치에는 영향을 받지 않고</a:t>
+            </a:r>
+            <a:r>
+              <a:rPr lang="en-US" altLang="ko-KR" dirty="0"/>
+              <a:t>, </a:t>
+            </a:r>
+            <a:r>
+              <a:rPr lang="ko-KR" altLang="en-US" dirty="0"/>
+              <a:t>태양을 회전시키면 빛이 변화한다</a:t>
+            </a:r>
+            <a:r>
+              <a:rPr lang="en-US" altLang="ko-KR" dirty="0"/>
+              <a:t>.</a:t>
+            </a:r>
+          </a:p>
+          <a:p>
+            <a:r>
+              <a:rPr lang="en-US" altLang="ko-KR" dirty="0"/>
+              <a:t>Point Light : </a:t>
+            </a:r>
+            <a:r>
+              <a:rPr lang="ko-KR" altLang="en-US" dirty="0"/>
+              <a:t>조명</a:t>
+            </a:r>
+            <a:r>
+              <a:rPr lang="en-US" altLang="ko-KR" dirty="0"/>
+              <a:t>, </a:t>
+            </a:r>
+            <a:r>
+              <a:rPr lang="ko-KR" altLang="en-US" dirty="0" err="1"/>
+              <a:t>전구같은</a:t>
+            </a:r>
+            <a:r>
+              <a:rPr lang="ko-KR" altLang="en-US" dirty="0"/>
+              <a:t> 거라고 생각하면 됨</a:t>
+            </a:r>
+            <a:r>
+              <a:rPr lang="en-US" altLang="ko-KR" dirty="0"/>
+              <a:t>. </a:t>
+            </a:r>
+            <a:r>
+              <a:rPr lang="ko-KR" altLang="en-US" dirty="0"/>
+              <a:t>가운데를 중심으로 빛이 </a:t>
+            </a:r>
+            <a:r>
+              <a:rPr lang="ko-KR" altLang="en-US" dirty="0" err="1"/>
+              <a:t>퍼져나가는</a:t>
+            </a:r>
+            <a:r>
+              <a:rPr lang="ko-KR" altLang="en-US" dirty="0"/>
+              <a:t> 모습</a:t>
+            </a:r>
+            <a:r>
+              <a:rPr lang="en-US" altLang="ko-KR" dirty="0"/>
+              <a:t>. </a:t>
+            </a:r>
+            <a:r>
+              <a:rPr lang="ko-KR" altLang="en-US" dirty="0"/>
+              <a:t>빛의 위치에 따라 빛의 영향을 받는 위치가 달라진다</a:t>
+            </a:r>
+            <a:r>
+              <a:rPr lang="en-US" altLang="ko-KR" dirty="0"/>
+              <a:t>. Range</a:t>
+            </a:r>
+            <a:r>
+              <a:rPr lang="ko-KR" altLang="en-US" dirty="0"/>
+              <a:t>를 통해 확산되는 범위 조절 가능</a:t>
+            </a:r>
+            <a:endParaRPr lang="en-US" altLang="ko-KR" dirty="0"/>
+          </a:p>
+          <a:p>
+            <a:r>
+              <a:rPr lang="en-US" altLang="ko-KR" dirty="0"/>
+              <a:t>Spot Light : </a:t>
+            </a:r>
+            <a:r>
+              <a:rPr lang="ko-KR" altLang="en-US" dirty="0"/>
+              <a:t>무대의 </a:t>
+            </a:r>
+            <a:r>
+              <a:rPr lang="ko-KR" altLang="en-US" dirty="0" err="1"/>
+              <a:t>스팟</a:t>
+            </a:r>
+            <a:r>
+              <a:rPr lang="ko-KR" altLang="en-US" dirty="0"/>
+              <a:t> 라이트</a:t>
+            </a:r>
+            <a:r>
+              <a:rPr lang="en-US" altLang="ko-KR" dirty="0"/>
+              <a:t>. </a:t>
+            </a:r>
+            <a:r>
+              <a:rPr lang="ko-KR" altLang="en-US" dirty="0"/>
+              <a:t>한 곳에 집중되는 조명</a:t>
+            </a:r>
+            <a:r>
+              <a:rPr lang="en-US" altLang="ko-KR" dirty="0"/>
+              <a:t>.</a:t>
+            </a:r>
+          </a:p>
+          <a:p>
+            <a:r>
+              <a:rPr lang="en-US" altLang="ko-KR" dirty="0"/>
+              <a:t>Area Light : Baked</a:t>
+            </a:r>
+            <a:r>
+              <a:rPr lang="ko-KR" altLang="en-US" dirty="0"/>
+              <a:t>일 때만 사용 가능</a:t>
+            </a:r>
+            <a:r>
+              <a:rPr lang="en-US" altLang="ko-KR" dirty="0"/>
+              <a:t>. </a:t>
+            </a:r>
+            <a:r>
+              <a:rPr lang="ko-KR" altLang="en-US" dirty="0"/>
+              <a:t>네모 영역에서부터 흰 선의 방향으로 빛이 </a:t>
+            </a:r>
+            <a:r>
+              <a:rPr lang="ko-KR" altLang="en-US" dirty="0" err="1"/>
+              <a:t>뻗어나간다</a:t>
+            </a:r>
+            <a:r>
+              <a:rPr lang="en-US" altLang="ko-KR" dirty="0"/>
+              <a:t>.</a:t>
+            </a:r>
+            <a:endParaRPr lang="ko-KR" altLang="en-US" dirty="0"/>
+          </a:p>
+        </p:txBody>
+      </p:sp>
+    </p:spTree>
+    <p:extLst>
+      <p:ext uri="{BB962C8B-B14F-4D97-AF65-F5344CB8AC3E}">
+        <p14:creationId xmlns:p14="http://schemas.microsoft.com/office/powerpoint/2010/main" val="1955580070"/>
+      </p:ext>
+    </p:extLst>
+  </p:cSld>
+  <p:clrMapOvr>
+    <a:masterClrMapping/>
+  </p:clrMapOvr>
+</p:sld>
+</file>
+
+<file path=ppt/slides/slide4.xml><?xml version="1.0" encoding="utf-8"?>
+<p:sld xmlns:a="http://schemas.openxmlformats.org/drawingml/2006/main" xmlns:r="http://schemas.openxmlformats.org/officeDocument/2006/relationships" xmlns:p="http://schemas.openxmlformats.org/presentationml/2006/main">
+  <p:cSld>
+    <p:spTree>
+      <p:nvGrpSpPr>
+        <p:cNvPr id="1" name=""/>
+        <p:cNvGrpSpPr/>
+        <p:nvPr/>
+      </p:nvGrpSpPr>
+      <p:grpSpPr>
+        <a:xfrm>
+          <a:off x="0" y="0"/>
+          <a:ext cx="0" cy="0"/>
+          <a:chOff x="0" y="0"/>
+          <a:chExt cx="0" cy="0"/>
+        </a:xfrm>
+      </p:grpSpPr>
+      <p:sp>
+        <p:nvSpPr>
+          <p:cNvPr id="2" name="제목 1">
+            <a:extLst>
+              <a:ext uri="{FF2B5EF4-FFF2-40B4-BE49-F238E27FC236}">
+                <a16:creationId xmlns:a16="http://schemas.microsoft.com/office/drawing/2014/main" id="{F2316944-20F9-53E3-AFCE-C892274AB6C8}"/>
+              </a:ext>
+            </a:extLst>
+          </p:cNvPr>
+          <p:cNvSpPr>
+            <a:spLocks noGrp="1"/>
+          </p:cNvSpPr>
+          <p:nvPr>
+            <p:ph type="title"/>
+          </p:nvPr>
+        </p:nvSpPr>
+        <p:spPr/>
+        <p:txBody>
+          <a:bodyPr/>
+          <a:lstStyle/>
+          <a:p>
+            <a:r>
+              <a:rPr lang="en-US" altLang="ko-KR" dirty="0"/>
+              <a:t>Prefab</a:t>
+            </a:r>
+            <a:endParaRPr lang="ko-KR" altLang="en-US" dirty="0"/>
+          </a:p>
+        </p:txBody>
+      </p:sp>
+      <p:sp>
+        <p:nvSpPr>
+          <p:cNvPr id="3" name="내용 개체 틀 2">
+            <a:extLst>
+              <a:ext uri="{FF2B5EF4-FFF2-40B4-BE49-F238E27FC236}">
+                <a16:creationId xmlns:a16="http://schemas.microsoft.com/office/drawing/2014/main" id="{9623A604-AE2D-6B2C-B521-5A7F280DF799}"/>
+              </a:ext>
+            </a:extLst>
+          </p:cNvPr>
+          <p:cNvSpPr>
+            <a:spLocks noGrp="1"/>
+          </p:cNvSpPr>
+          <p:nvPr>
+            <p:ph idx="1"/>
+          </p:nvPr>
+        </p:nvSpPr>
+        <p:spPr>
+          <a:xfrm>
+            <a:off x="838200" y="1474470"/>
+            <a:ext cx="10515600" cy="5018405"/>
+          </a:xfrm>
+        </p:spPr>
+        <p:txBody>
+          <a:bodyPr>
+            <a:normAutofit fontScale="85000" lnSpcReduction="10000"/>
+          </a:bodyPr>
+          <a:lstStyle/>
+          <a:p>
+            <a:r>
+              <a:rPr lang="ko-KR" altLang="en-US" dirty="0" err="1"/>
+              <a:t>에셋을</a:t>
+            </a:r>
+            <a:r>
+              <a:rPr lang="ko-KR" altLang="en-US" dirty="0"/>
+              <a:t> 재사용하기 위한 기능</a:t>
+            </a:r>
+            <a:endParaRPr lang="en-US" altLang="ko-KR" dirty="0"/>
+          </a:p>
+          <a:p>
+            <a:r>
+              <a:rPr lang="en-US" altLang="ko-KR" dirty="0"/>
+              <a:t>Project </a:t>
+            </a:r>
+            <a:r>
+              <a:rPr lang="ko-KR" altLang="en-US" dirty="0"/>
+              <a:t>쪽에 있는 게 원본</a:t>
+            </a:r>
+            <a:r>
+              <a:rPr lang="en-US" altLang="ko-KR" dirty="0"/>
+              <a:t>. Hierarchy </a:t>
+            </a:r>
+            <a:r>
+              <a:rPr lang="ko-KR" altLang="en-US" dirty="0"/>
+              <a:t>쪽에 있는 건 개별적인 오브젝트</a:t>
+            </a:r>
+            <a:r>
+              <a:rPr lang="en-US" altLang="ko-KR" dirty="0"/>
+              <a:t>. </a:t>
+            </a:r>
+            <a:r>
+              <a:rPr lang="ko-KR" altLang="en-US" dirty="0"/>
+              <a:t>개별 오브젝트에서 어떤 것을 수정하면</a:t>
+            </a:r>
+            <a:r>
+              <a:rPr lang="en-US" altLang="ko-KR" dirty="0"/>
+              <a:t>, </a:t>
+            </a:r>
+            <a:r>
+              <a:rPr lang="ko-KR" altLang="en-US" dirty="0"/>
+              <a:t>그 부분의 글자는 굵게</a:t>
+            </a:r>
+            <a:r>
+              <a:rPr lang="en-US" altLang="ko-KR" dirty="0"/>
+              <a:t> </a:t>
+            </a:r>
+            <a:r>
+              <a:rPr lang="ko-KR" altLang="en-US" dirty="0"/>
+              <a:t>표시되고 </a:t>
+            </a:r>
+            <a:r>
+              <a:rPr lang="ko-KR" altLang="en-US" dirty="0" err="1"/>
+              <a:t>파랑색</a:t>
+            </a:r>
+            <a:r>
+              <a:rPr lang="ko-KR" altLang="en-US" dirty="0"/>
+              <a:t> 선이 생긴다</a:t>
+            </a:r>
+            <a:r>
+              <a:rPr lang="en-US" altLang="ko-KR" dirty="0"/>
+              <a:t>.</a:t>
+            </a:r>
+          </a:p>
+          <a:p>
+            <a:r>
+              <a:rPr lang="ko-KR" altLang="en-US" dirty="0"/>
+              <a:t>이렇게 개별적으로 오브젝트를 수정했는데</a:t>
+            </a:r>
+            <a:r>
+              <a:rPr lang="en-US" altLang="ko-KR" dirty="0"/>
+              <a:t>, </a:t>
+            </a:r>
+            <a:r>
+              <a:rPr lang="ko-KR" altLang="en-US" dirty="0"/>
+              <a:t>이걸 모든 같은 </a:t>
+            </a:r>
+            <a:r>
+              <a:rPr lang="ko-KR" altLang="en-US" dirty="0" err="1"/>
+              <a:t>프리펩인</a:t>
+            </a:r>
+            <a:r>
+              <a:rPr lang="ko-KR" altLang="en-US" dirty="0"/>
+              <a:t> 오브젝트들에 적용하고 싶으면</a:t>
+            </a:r>
+            <a:r>
+              <a:rPr lang="en-US" altLang="ko-KR" dirty="0"/>
+              <a:t>, </a:t>
+            </a:r>
+            <a:r>
+              <a:rPr lang="ko-KR" altLang="en-US" dirty="0"/>
+              <a:t>그 변경된 값을 </a:t>
+            </a:r>
+            <a:r>
+              <a:rPr lang="ko-KR" altLang="en-US" dirty="0" err="1"/>
+              <a:t>우클릭</a:t>
+            </a:r>
+            <a:r>
+              <a:rPr lang="ko-KR" altLang="en-US" dirty="0"/>
+              <a:t> 해서 </a:t>
+            </a:r>
+            <a:r>
+              <a:rPr lang="en-US" altLang="ko-KR" dirty="0"/>
+              <a:t>“Apply to Prefab ‘</a:t>
+            </a:r>
+            <a:r>
+              <a:rPr lang="ko-KR" altLang="en-US" dirty="0" err="1"/>
+              <a:t>프리펩이름</a:t>
+            </a:r>
+            <a:r>
+              <a:rPr lang="en-US" altLang="ko-KR" dirty="0"/>
+              <a:t>’”</a:t>
+            </a:r>
+            <a:r>
+              <a:rPr lang="ko-KR" altLang="en-US" dirty="0"/>
+              <a:t>을</a:t>
+            </a:r>
+            <a:r>
+              <a:rPr lang="en-US" altLang="ko-KR" dirty="0"/>
+              <a:t> </a:t>
+            </a:r>
+            <a:r>
+              <a:rPr lang="ko-KR" altLang="en-US" dirty="0"/>
+              <a:t>클릭하면 원본 </a:t>
+            </a:r>
+            <a:r>
+              <a:rPr lang="ko-KR" altLang="en-US" dirty="0" err="1"/>
+              <a:t>프리펩에도</a:t>
+            </a:r>
+            <a:r>
+              <a:rPr lang="ko-KR" altLang="en-US" dirty="0"/>
+              <a:t> 변경 사항이 저장되고</a:t>
+            </a:r>
+            <a:r>
+              <a:rPr lang="en-US" altLang="ko-KR" dirty="0"/>
+              <a:t>, </a:t>
+            </a:r>
+            <a:r>
+              <a:rPr lang="ko-KR" altLang="en-US" dirty="0"/>
+              <a:t>같은 </a:t>
+            </a:r>
+            <a:r>
+              <a:rPr lang="ko-KR" altLang="en-US" dirty="0" err="1"/>
+              <a:t>프리펩인</a:t>
+            </a:r>
+            <a:r>
+              <a:rPr lang="ko-KR" altLang="en-US" dirty="0"/>
+              <a:t> </a:t>
+            </a:r>
+            <a:r>
+              <a:rPr lang="ko-KR" altLang="en-US" dirty="0" err="1"/>
+              <a:t>오브젝트들에도</a:t>
+            </a:r>
+            <a:r>
+              <a:rPr lang="ko-KR" altLang="en-US" dirty="0"/>
+              <a:t> 모두 적용된다</a:t>
+            </a:r>
+            <a:r>
+              <a:rPr lang="en-US" altLang="ko-KR" dirty="0"/>
+              <a:t>.</a:t>
+            </a:r>
+          </a:p>
+          <a:p>
+            <a:r>
+              <a:rPr lang="ko-KR" altLang="en-US" dirty="0"/>
+              <a:t>또 </a:t>
+            </a:r>
+            <a:r>
+              <a:rPr lang="en-US" altLang="ko-KR" dirty="0"/>
+              <a:t>Hierarchy</a:t>
+            </a:r>
+            <a:r>
+              <a:rPr lang="ko-KR" altLang="en-US" dirty="0"/>
+              <a:t>에서 개별 오브젝트를 수정 후</a:t>
+            </a:r>
+            <a:r>
+              <a:rPr lang="en-US" altLang="ko-KR" dirty="0"/>
+              <a:t>, Inspector</a:t>
+            </a:r>
+            <a:r>
+              <a:rPr lang="ko-KR" altLang="en-US" dirty="0"/>
+              <a:t>에서 </a:t>
+            </a:r>
+            <a:r>
+              <a:rPr lang="en-US" altLang="ko-KR" dirty="0"/>
+              <a:t>Overrides</a:t>
+            </a:r>
+            <a:r>
+              <a:rPr lang="ko-KR" altLang="en-US" dirty="0"/>
+              <a:t>를 클릭해서 </a:t>
+            </a:r>
+            <a:r>
+              <a:rPr lang="en-US" altLang="ko-KR" dirty="0"/>
+              <a:t>‘Apply All’</a:t>
+            </a:r>
+            <a:r>
+              <a:rPr lang="ko-KR" altLang="en-US" dirty="0"/>
+              <a:t>을</a:t>
+            </a:r>
+            <a:r>
+              <a:rPr lang="en-US" altLang="ko-KR" dirty="0"/>
+              <a:t> </a:t>
+            </a:r>
+            <a:r>
+              <a:rPr lang="ko-KR" altLang="en-US" dirty="0"/>
+              <a:t>클릭하면 개별 오브젝트의 변경 사항을 원본 </a:t>
+            </a:r>
+            <a:r>
+              <a:rPr lang="ko-KR" altLang="en-US" dirty="0" err="1"/>
+              <a:t>프리펩</a:t>
+            </a:r>
+            <a:r>
+              <a:rPr lang="ko-KR" altLang="en-US" dirty="0"/>
+              <a:t> </a:t>
+            </a:r>
+            <a:r>
+              <a:rPr lang="en-US" altLang="ko-KR" dirty="0"/>
+              <a:t>+ </a:t>
+            </a:r>
+            <a:r>
+              <a:rPr lang="ko-KR" altLang="en-US" dirty="0"/>
+              <a:t>같은 </a:t>
+            </a:r>
+            <a:r>
+              <a:rPr lang="ko-KR" altLang="en-US" dirty="0" err="1"/>
+              <a:t>프리펩의</a:t>
+            </a:r>
+            <a:r>
+              <a:rPr lang="ko-KR" altLang="en-US" dirty="0"/>
+              <a:t> 오브젝트들 모두에 적용하게 되고</a:t>
+            </a:r>
+            <a:r>
+              <a:rPr lang="en-US" altLang="ko-KR" dirty="0"/>
+              <a:t>, ‘Revert All’</a:t>
+            </a:r>
+            <a:r>
+              <a:rPr lang="ko-KR" altLang="en-US" dirty="0"/>
+              <a:t>을</a:t>
+            </a:r>
+            <a:r>
+              <a:rPr lang="en-US" altLang="ko-KR" dirty="0"/>
+              <a:t> </a:t>
+            </a:r>
+            <a:r>
+              <a:rPr lang="ko-KR" altLang="en-US" dirty="0"/>
+              <a:t>클릭하면 개별 오브젝트의 변경사항이 원본 </a:t>
+            </a:r>
+            <a:r>
+              <a:rPr lang="ko-KR" altLang="en-US" dirty="0" err="1"/>
+              <a:t>프리펩으로</a:t>
+            </a:r>
+            <a:r>
+              <a:rPr lang="ko-KR" altLang="en-US" dirty="0"/>
+              <a:t> 다시 되돌아간다</a:t>
+            </a:r>
+            <a:r>
+              <a:rPr lang="en-US" altLang="ko-KR" dirty="0"/>
+              <a:t>.</a:t>
+            </a:r>
+          </a:p>
+          <a:p>
+            <a:r>
+              <a:rPr lang="ko-KR" altLang="en-US" dirty="0"/>
+              <a:t>또 </a:t>
+            </a:r>
+            <a:r>
+              <a:rPr lang="en-US" altLang="ko-KR" dirty="0"/>
+              <a:t>Project</a:t>
+            </a:r>
+            <a:r>
+              <a:rPr lang="ko-KR" altLang="en-US" dirty="0"/>
+              <a:t>에서 원본 </a:t>
+            </a:r>
+            <a:r>
+              <a:rPr lang="ko-KR" altLang="en-US" dirty="0" err="1"/>
+              <a:t>프리펩을</a:t>
+            </a:r>
+            <a:r>
+              <a:rPr lang="ko-KR" altLang="en-US" dirty="0"/>
+              <a:t> </a:t>
+            </a:r>
+            <a:r>
+              <a:rPr lang="ko-KR" altLang="en-US" dirty="0" err="1"/>
+              <a:t>더블클릭해서</a:t>
+            </a:r>
+            <a:r>
+              <a:rPr lang="ko-KR" altLang="en-US" dirty="0"/>
+              <a:t> 원본 </a:t>
+            </a:r>
+            <a:r>
+              <a:rPr lang="ko-KR" altLang="en-US" dirty="0" err="1"/>
+              <a:t>프리펩을</a:t>
+            </a:r>
+            <a:r>
+              <a:rPr lang="ko-KR" altLang="en-US" dirty="0"/>
+              <a:t> 편집하게 되면</a:t>
+            </a:r>
+            <a:r>
+              <a:rPr lang="en-US" altLang="ko-KR" dirty="0"/>
+              <a:t>, (Auto Save</a:t>
+            </a:r>
+            <a:r>
+              <a:rPr lang="ko-KR" altLang="en-US" dirty="0"/>
+              <a:t>가 켜진 경우에는 실시간으로</a:t>
+            </a:r>
+            <a:r>
+              <a:rPr lang="en-US" altLang="ko-KR" dirty="0"/>
+              <a:t>) </a:t>
+            </a:r>
+            <a:r>
+              <a:rPr lang="ko-KR" altLang="en-US" dirty="0"/>
+              <a:t>저장하면 바로 변경 사항이 모든 오브젝트들에 적용된다</a:t>
+            </a:r>
+            <a:r>
+              <a:rPr lang="en-US" altLang="ko-KR" dirty="0"/>
+              <a:t>.</a:t>
+            </a:r>
+          </a:p>
+        </p:txBody>
+      </p:sp>
+    </p:spTree>
+    <p:extLst>
+      <p:ext uri="{BB962C8B-B14F-4D97-AF65-F5344CB8AC3E}">
+        <p14:creationId xmlns:p14="http://schemas.microsoft.com/office/powerpoint/2010/main" val="2089986495"/>
+      </p:ext>
+    </p:extLst>
+  </p:cSld>
+  <p:clrMapOvr>
+    <a:masterClrMapping/>
+  </p:clrMapOvr>
+</p:sld>
+</file>
+
+<file path=ppt/slides/slide5.xml><?xml version="1.0" encoding="utf-8"?>
+<p:sld xmlns:a="http://schemas.openxmlformats.org/drawingml/2006/main" xmlns:r="http://schemas.openxmlformats.org/officeDocument/2006/relationships" xmlns:p="http://schemas.openxmlformats.org/presentationml/2006/main">
+  <p:cSld>
+    <p:spTree>
+      <p:nvGrpSpPr>
+        <p:cNvPr id="1" name=""/>
+        <p:cNvGrpSpPr/>
+        <p:nvPr/>
+      </p:nvGrpSpPr>
+      <p:grpSpPr>
+        <a:xfrm>
+          <a:off x="0" y="0"/>
+          <a:ext cx="0" cy="0"/>
+          <a:chOff x="0" y="0"/>
+          <a:chExt cx="0" cy="0"/>
+        </a:xfrm>
+      </p:grpSpPr>
+      <p:sp>
+        <p:nvSpPr>
+          <p:cNvPr id="2" name="제목 1">
+            <a:extLst>
+              <a:ext uri="{FF2B5EF4-FFF2-40B4-BE49-F238E27FC236}">
+                <a16:creationId xmlns:a16="http://schemas.microsoft.com/office/drawing/2014/main" id="{44DB9A97-90B0-AE13-65D6-E37B3ADD7A68}"/>
+              </a:ext>
+            </a:extLst>
+          </p:cNvPr>
+          <p:cNvSpPr>
+            <a:spLocks noGrp="1"/>
+          </p:cNvSpPr>
+          <p:nvPr>
+            <p:ph type="title"/>
+          </p:nvPr>
+        </p:nvSpPr>
+        <p:spPr/>
+        <p:txBody>
+          <a:bodyPr/>
+          <a:lstStyle/>
+          <a:p>
+            <a:r>
+              <a:rPr lang="en-US" altLang="ko-KR" dirty="0"/>
+              <a:t>Prefab </a:t>
+            </a:r>
+            <a:r>
+              <a:rPr lang="ko-KR" altLang="en-US" dirty="0"/>
+              <a:t>연결 끊기</a:t>
+            </a:r>
+          </a:p>
+        </p:txBody>
+      </p:sp>
+      <p:sp>
+        <p:nvSpPr>
+          <p:cNvPr id="3" name="내용 개체 틀 2">
+            <a:extLst>
+              <a:ext uri="{FF2B5EF4-FFF2-40B4-BE49-F238E27FC236}">
+                <a16:creationId xmlns:a16="http://schemas.microsoft.com/office/drawing/2014/main" id="{B4407594-6D22-3AEE-188C-1645176B7FF3}"/>
+              </a:ext>
+            </a:extLst>
+          </p:cNvPr>
+          <p:cNvSpPr>
+            <a:spLocks noGrp="1"/>
+          </p:cNvSpPr>
+          <p:nvPr>
+            <p:ph idx="1"/>
+          </p:nvPr>
+        </p:nvSpPr>
+        <p:spPr/>
+        <p:txBody>
+          <a:bodyPr/>
+          <a:lstStyle/>
+          <a:p>
+            <a:r>
+              <a:rPr lang="en-US" altLang="ko-KR" dirty="0"/>
+              <a:t>Prefab </a:t>
+            </a:r>
+            <a:r>
+              <a:rPr lang="ko-KR" altLang="en-US" dirty="0"/>
+              <a:t>연결을 끊고 싶은 오브젝트 </a:t>
+            </a:r>
+            <a:r>
+              <a:rPr lang="ko-KR" altLang="en-US" dirty="0" err="1"/>
+              <a:t>우클릭</a:t>
+            </a:r>
+            <a:r>
+              <a:rPr lang="ko-KR" altLang="en-US" dirty="0"/>
+              <a:t> </a:t>
+            </a:r>
+            <a:r>
+              <a:rPr lang="en-US" altLang="ko-KR" dirty="0"/>
+              <a:t>-&gt; Unpack</a:t>
+            </a:r>
+          </a:p>
+          <a:p>
+            <a:r>
+              <a:rPr lang="ko-KR" altLang="en-US" dirty="0"/>
+              <a:t>연결을 끊게 되면</a:t>
+            </a:r>
+            <a:r>
+              <a:rPr lang="en-US" altLang="ko-KR" dirty="0"/>
+              <a:t>, </a:t>
+            </a:r>
+            <a:r>
+              <a:rPr lang="ko-KR" altLang="en-US" dirty="0"/>
+              <a:t>해당 오브젝트는 독립적인 오브젝트가 된다</a:t>
+            </a:r>
+            <a:r>
+              <a:rPr lang="en-US" altLang="ko-KR" dirty="0"/>
+              <a:t>.</a:t>
+            </a:r>
+          </a:p>
+          <a:p>
+            <a:r>
+              <a:rPr lang="ko-KR" altLang="en-US" dirty="0"/>
+              <a:t>즉</a:t>
+            </a:r>
+            <a:r>
+              <a:rPr lang="en-US" altLang="ko-KR" dirty="0"/>
+              <a:t>, </a:t>
+            </a:r>
+            <a:r>
+              <a:rPr lang="ko-KR" altLang="en-US" dirty="0"/>
+              <a:t>이제 원본 </a:t>
+            </a:r>
+            <a:r>
+              <a:rPr lang="en-US" altLang="ko-KR" dirty="0"/>
+              <a:t>prefab</a:t>
+            </a:r>
+            <a:r>
+              <a:rPr lang="ko-KR" altLang="en-US" dirty="0"/>
+              <a:t>을 수정해도</a:t>
+            </a:r>
+            <a:r>
+              <a:rPr lang="en-US" altLang="ko-KR" dirty="0"/>
+              <a:t>, </a:t>
+            </a:r>
+            <a:r>
+              <a:rPr lang="ko-KR" altLang="en-US" dirty="0"/>
+              <a:t>연결을 끊은 오브젝트는 그 수정사항이 반영되지 않게 되는 것</a:t>
+            </a:r>
+            <a:r>
+              <a:rPr lang="en-US" altLang="ko-KR" dirty="0"/>
+              <a:t>.</a:t>
+            </a:r>
+          </a:p>
+          <a:p>
+            <a:r>
+              <a:rPr lang="ko-KR" altLang="en-US" dirty="0"/>
+              <a:t>주의 </a:t>
+            </a:r>
+            <a:r>
+              <a:rPr lang="en-US" altLang="ko-KR" dirty="0"/>
+              <a:t>! : </a:t>
+            </a:r>
+            <a:r>
+              <a:rPr lang="ko-KR" altLang="en-US" dirty="0"/>
+              <a:t>한 번 </a:t>
+            </a:r>
+            <a:r>
+              <a:rPr lang="en-US" altLang="ko-KR" dirty="0"/>
+              <a:t>Unpack</a:t>
+            </a:r>
+            <a:r>
+              <a:rPr lang="ko-KR" altLang="en-US" dirty="0"/>
+              <a:t>을 하게 되면</a:t>
+            </a:r>
+            <a:r>
+              <a:rPr lang="en-US" altLang="ko-KR" dirty="0"/>
+              <a:t>, </a:t>
+            </a:r>
+            <a:r>
+              <a:rPr lang="ko-KR" altLang="en-US" dirty="0"/>
+              <a:t>다시 </a:t>
+            </a:r>
+            <a:r>
+              <a:rPr lang="en-US" altLang="ko-KR" dirty="0"/>
+              <a:t>Prefab</a:t>
+            </a:r>
+            <a:r>
+              <a:rPr lang="ko-KR" altLang="en-US" dirty="0"/>
+              <a:t>에 연결할 수 없다</a:t>
+            </a:r>
+            <a:r>
+              <a:rPr lang="en-US" altLang="ko-KR" dirty="0"/>
+              <a:t>.(</a:t>
+            </a:r>
+            <a:r>
+              <a:rPr lang="ko-KR" altLang="en-US" dirty="0"/>
+              <a:t>원본 </a:t>
+            </a:r>
+            <a:r>
+              <a:rPr lang="en-US" altLang="ko-KR" dirty="0" err="1"/>
+              <a:t>prefa</a:t>
+            </a:r>
+            <a:r>
+              <a:rPr lang="ko-KR" altLang="en-US" dirty="0"/>
+              <a:t>을 참조할 수 없다</a:t>
+            </a:r>
+            <a:r>
+              <a:rPr lang="en-US" altLang="ko-KR" dirty="0"/>
+              <a:t>.)</a:t>
+            </a:r>
+            <a:br>
+              <a:rPr lang="en-US" altLang="ko-KR" dirty="0"/>
+            </a:br>
+            <a:r>
+              <a:rPr lang="ko-KR" altLang="en-US" dirty="0"/>
+              <a:t>따라서 </a:t>
+            </a:r>
+            <a:r>
+              <a:rPr lang="en-US" altLang="ko-KR" dirty="0"/>
+              <a:t>Unpack</a:t>
+            </a:r>
+            <a:r>
+              <a:rPr lang="ko-KR" altLang="en-US" dirty="0"/>
+              <a:t>할 때는 조심해야 한다</a:t>
+            </a:r>
+            <a:r>
+              <a:rPr lang="en-US" altLang="ko-KR" dirty="0"/>
+              <a:t>.</a:t>
+            </a:r>
+            <a:endParaRPr lang="ko-KR" altLang="en-US" dirty="0"/>
+          </a:p>
+        </p:txBody>
+      </p:sp>
+    </p:spTree>
+    <p:extLst>
+      <p:ext uri="{BB962C8B-B14F-4D97-AF65-F5344CB8AC3E}">
+        <p14:creationId xmlns:p14="http://schemas.microsoft.com/office/powerpoint/2010/main" val="1398924051"/>
+      </p:ext>
+    </p:extLst>
+  </p:cSld>
+  <p:clrMapOvr>
+    <a:masterClrMapping/>
+  </p:clrMapOvr>
+</p:sld>
+</file>
+
+<file path=ppt/slides/slide6.xml><?xml version="1.0" encoding="utf-8"?>
+<p:sld xmlns:a="http://schemas.openxmlformats.org/drawingml/2006/main" xmlns:r="http://schemas.openxmlformats.org/officeDocument/2006/relationships" xmlns:p="http://schemas.openxmlformats.org/presentationml/2006/main">
+  <p:cSld>
+    <p:spTree>
+      <p:nvGrpSpPr>
+        <p:cNvPr id="1" name=""/>
+        <p:cNvGrpSpPr/>
+        <p:nvPr/>
+      </p:nvGrpSpPr>
+      <p:grpSpPr>
+        <a:xfrm>
+          <a:off x="0" y="0"/>
+          <a:ext cx="0" cy="0"/>
+          <a:chOff x="0" y="0"/>
+          <a:chExt cx="0" cy="0"/>
+        </a:xfrm>
+      </p:grpSpPr>
+      <p:sp>
+        <p:nvSpPr>
+          <p:cNvPr id="2" name="제목 1">
+            <a:extLst>
+              <a:ext uri="{FF2B5EF4-FFF2-40B4-BE49-F238E27FC236}">
+                <a16:creationId xmlns:a16="http://schemas.microsoft.com/office/drawing/2014/main" id="{30ABF29C-6B14-64C5-E35C-D6269D66E9F0}"/>
+              </a:ext>
+            </a:extLst>
+          </p:cNvPr>
+          <p:cNvSpPr>
+            <a:spLocks noGrp="1"/>
+          </p:cNvSpPr>
+          <p:nvPr>
+            <p:ph type="title"/>
+          </p:nvPr>
+        </p:nvSpPr>
+        <p:spPr/>
+        <p:txBody>
+          <a:bodyPr/>
+          <a:lstStyle/>
+          <a:p>
+            <a:r>
+              <a:rPr lang="ko-KR" altLang="en-US" dirty="0"/>
+              <a:t>원본 </a:t>
+            </a:r>
+            <a:r>
+              <a:rPr lang="en-US" altLang="ko-KR" dirty="0"/>
+              <a:t>Prefab</a:t>
+            </a:r>
+            <a:r>
+              <a:rPr lang="ko-KR" altLang="en-US" dirty="0"/>
+              <a:t>을</a:t>
+            </a:r>
+            <a:r>
+              <a:rPr lang="en-US" altLang="ko-KR" dirty="0"/>
+              <a:t> </a:t>
+            </a:r>
+            <a:r>
+              <a:rPr lang="ko-KR" altLang="en-US" dirty="0"/>
+              <a:t>제거하는 경우</a:t>
+            </a:r>
+          </a:p>
+        </p:txBody>
+      </p:sp>
+      <p:sp>
+        <p:nvSpPr>
+          <p:cNvPr id="3" name="내용 개체 틀 2">
+            <a:extLst>
+              <a:ext uri="{FF2B5EF4-FFF2-40B4-BE49-F238E27FC236}">
+                <a16:creationId xmlns:a16="http://schemas.microsoft.com/office/drawing/2014/main" id="{EFED090A-EB0D-78CC-ADBA-2EDC9FCE8F90}"/>
+              </a:ext>
+            </a:extLst>
+          </p:cNvPr>
+          <p:cNvSpPr>
+            <a:spLocks noGrp="1"/>
+          </p:cNvSpPr>
+          <p:nvPr>
+            <p:ph idx="1"/>
+          </p:nvPr>
+        </p:nvSpPr>
+        <p:spPr/>
+        <p:txBody>
+          <a:bodyPr>
+            <a:normAutofit lnSpcReduction="10000"/>
+          </a:bodyPr>
+          <a:lstStyle/>
+          <a:p>
+            <a:r>
+              <a:rPr lang="ko-KR" altLang="en-US" dirty="0"/>
+              <a:t>그러면 참조하던 모든 오브젝트들이 모두 붉은 색 글자로 표시된다</a:t>
+            </a:r>
+            <a:r>
+              <a:rPr lang="en-US" altLang="ko-KR" dirty="0"/>
+              <a:t>.</a:t>
+            </a:r>
+          </a:p>
+          <a:p>
+            <a:r>
+              <a:rPr lang="ko-KR" altLang="en-US" dirty="0"/>
+              <a:t>이는 원본 </a:t>
+            </a:r>
+            <a:r>
+              <a:rPr lang="en-US" altLang="ko-KR" dirty="0"/>
+              <a:t>prefab</a:t>
+            </a:r>
+            <a:r>
+              <a:rPr lang="ko-KR" altLang="en-US" dirty="0"/>
+              <a:t>이 사라져서 참조할 수 없는 상태</a:t>
+            </a:r>
+            <a:r>
+              <a:rPr lang="en-US" altLang="ko-KR" dirty="0"/>
+              <a:t>(Missing)</a:t>
+            </a:r>
+            <a:r>
+              <a:rPr lang="ko-KR" altLang="en-US" dirty="0"/>
+              <a:t>를 의미한다</a:t>
+            </a:r>
+            <a:r>
+              <a:rPr lang="en-US" altLang="ko-KR" dirty="0"/>
+              <a:t>.</a:t>
+            </a:r>
+          </a:p>
+          <a:p>
+            <a:r>
+              <a:rPr lang="ko-KR" altLang="en-US" dirty="0"/>
+              <a:t>이럴 경우</a:t>
+            </a:r>
+            <a:r>
+              <a:rPr lang="en-US" altLang="ko-KR" dirty="0"/>
+              <a:t>, </a:t>
+            </a:r>
+            <a:r>
+              <a:rPr lang="ko-KR" altLang="en-US" dirty="0"/>
+              <a:t>원본 </a:t>
+            </a:r>
+            <a:r>
+              <a:rPr lang="en-US" altLang="ko-KR" dirty="0"/>
+              <a:t>prefab</a:t>
+            </a:r>
+            <a:r>
+              <a:rPr lang="ko-KR" altLang="en-US" dirty="0"/>
+              <a:t>을 찾지 못하면 사용할 수 없게 된다</a:t>
+            </a:r>
+            <a:r>
+              <a:rPr lang="en-US" altLang="ko-KR" dirty="0"/>
+              <a:t>.</a:t>
+            </a:r>
+          </a:p>
+          <a:p>
+            <a:r>
+              <a:rPr lang="ko-KR" altLang="en-US" dirty="0"/>
+              <a:t>이럴 때는 그 오브젝트를 </a:t>
+            </a:r>
+            <a:r>
+              <a:rPr lang="en-US" altLang="ko-KR" dirty="0"/>
+              <a:t>Project</a:t>
+            </a:r>
+            <a:r>
+              <a:rPr lang="ko-KR" altLang="en-US" dirty="0"/>
+              <a:t>로 드래그해서 새로운 </a:t>
+            </a:r>
+            <a:r>
+              <a:rPr lang="en-US" altLang="ko-KR" dirty="0"/>
+              <a:t>Prefab</a:t>
+            </a:r>
+            <a:r>
+              <a:rPr lang="ko-KR" altLang="en-US" dirty="0"/>
+              <a:t>으로 만들어주면 된다</a:t>
+            </a:r>
+            <a:r>
+              <a:rPr lang="en-US" altLang="ko-KR" dirty="0"/>
+              <a:t>.</a:t>
+            </a:r>
+          </a:p>
+          <a:p>
+            <a:pPr marL="0" indent="0">
+              <a:buNone/>
+            </a:pPr>
+            <a:endParaRPr lang="en-US" altLang="ko-KR" dirty="0"/>
+          </a:p>
+          <a:p>
+            <a:r>
+              <a:rPr lang="ko-KR" altLang="en-US" dirty="0"/>
+              <a:t>그러나 가장 좋은 방법은 버전 관리를 통해 원본 </a:t>
+            </a:r>
+            <a:r>
+              <a:rPr lang="en-US" altLang="ko-KR" dirty="0" err="1"/>
+              <a:t>prefa</a:t>
+            </a:r>
+            <a:r>
+              <a:rPr lang="ko-KR" altLang="en-US" dirty="0"/>
+              <a:t>을 찾는 것이 가장 좋다</a:t>
+            </a:r>
+            <a:r>
+              <a:rPr lang="en-US" altLang="ko-KR" dirty="0"/>
+              <a:t>.</a:t>
+            </a:r>
+          </a:p>
+        </p:txBody>
+      </p:sp>
+    </p:spTree>
+    <p:extLst>
+      <p:ext uri="{BB962C8B-B14F-4D97-AF65-F5344CB8AC3E}">
+        <p14:creationId xmlns:p14="http://schemas.microsoft.com/office/powerpoint/2010/main" val="3596129955"/>
+      </p:ext>
+    </p:extLst>
+  </p:cSld>
+  <p:clrMapOvr>
+    <a:masterClrMapping/>
+  </p:clrMapOvr>
+</p:sld>
+</file>
+
+<file path=ppt/slides/slide7.xml><?xml version="1.0" encoding="utf-8"?>
+<p:sld xmlns:a="http://schemas.openxmlformats.org/drawingml/2006/main" xmlns:r="http://schemas.openxmlformats.org/officeDocument/2006/relationships" xmlns:p="http://schemas.openxmlformats.org/presentationml/2006/main">
+  <p:cSld>
+    <p:spTree>
+      <p:nvGrpSpPr>
+        <p:cNvPr id="1" name=""/>
+        <p:cNvGrpSpPr/>
+        <p:nvPr/>
+      </p:nvGrpSpPr>
+      <p:grpSpPr>
+        <a:xfrm>
+          <a:off x="0" y="0"/>
+          <a:ext cx="0" cy="0"/>
+          <a:chOff x="0" y="0"/>
+          <a:chExt cx="0" cy="0"/>
+        </a:xfrm>
+      </p:grpSpPr>
+      <p:sp>
+        <p:nvSpPr>
+          <p:cNvPr id="2" name="제목 1">
+            <a:extLst>
+              <a:ext uri="{FF2B5EF4-FFF2-40B4-BE49-F238E27FC236}">
+                <a16:creationId xmlns:a16="http://schemas.microsoft.com/office/drawing/2014/main" id="{08850BF9-D6A2-0952-1D95-FFAFBFCFA4E7}"/>
+              </a:ext>
+            </a:extLst>
+          </p:cNvPr>
+          <p:cNvSpPr>
+            <a:spLocks noGrp="1"/>
+          </p:cNvSpPr>
+          <p:nvPr>
+            <p:ph type="title"/>
+          </p:nvPr>
+        </p:nvSpPr>
+        <p:spPr/>
+        <p:txBody>
+          <a:bodyPr/>
+          <a:lstStyle/>
+          <a:p>
+            <a:r>
+              <a:rPr lang="en-US" altLang="ko-KR" dirty="0"/>
+              <a:t>Prefab</a:t>
+            </a:r>
+            <a:r>
+              <a:rPr lang="ko-KR" altLang="en-US" dirty="0"/>
+              <a:t>의 장점</a:t>
+            </a:r>
+          </a:p>
+        </p:txBody>
+      </p:sp>
+      <p:sp>
+        <p:nvSpPr>
+          <p:cNvPr id="3" name="내용 개체 틀 2">
+            <a:extLst>
+              <a:ext uri="{FF2B5EF4-FFF2-40B4-BE49-F238E27FC236}">
+                <a16:creationId xmlns:a16="http://schemas.microsoft.com/office/drawing/2014/main" id="{A84B518F-0111-D807-BBEB-E7BBF694ABB2}"/>
+              </a:ext>
+            </a:extLst>
+          </p:cNvPr>
+          <p:cNvSpPr>
+            <a:spLocks noGrp="1"/>
+          </p:cNvSpPr>
+          <p:nvPr>
+            <p:ph idx="1"/>
+          </p:nvPr>
+        </p:nvSpPr>
+        <p:spPr/>
+        <p:txBody>
+          <a:bodyPr/>
+          <a:lstStyle/>
+          <a:p>
+            <a:r>
+              <a:rPr lang="ko-KR" altLang="en-US" dirty="0"/>
+              <a:t>그냥 오브젝트들은 현재 </a:t>
+            </a:r>
+            <a:r>
+              <a:rPr lang="ko-KR" altLang="en-US" dirty="0" err="1"/>
+              <a:t>열려있는</a:t>
+            </a:r>
+            <a:r>
+              <a:rPr lang="ko-KR" altLang="en-US" dirty="0"/>
+              <a:t> </a:t>
+            </a:r>
+            <a:r>
+              <a:rPr lang="en-US" altLang="ko-KR" dirty="0"/>
+              <a:t>Scene</a:t>
+            </a:r>
+            <a:r>
+              <a:rPr lang="ko-KR" altLang="en-US" dirty="0"/>
+              <a:t>에서만 사용 가능</a:t>
+            </a:r>
+            <a:endParaRPr lang="en-US" altLang="ko-KR" dirty="0"/>
+          </a:p>
+          <a:p>
+            <a:endParaRPr lang="en-US" altLang="ko-KR" dirty="0"/>
+          </a:p>
+          <a:p>
+            <a:r>
+              <a:rPr lang="en-US" altLang="ko-KR" dirty="0"/>
+              <a:t>But </a:t>
+            </a:r>
+          </a:p>
+          <a:p>
+            <a:endParaRPr lang="en-US" altLang="ko-KR" dirty="0"/>
+          </a:p>
+          <a:p>
+            <a:r>
+              <a:rPr lang="en-US" altLang="ko-KR" dirty="0"/>
+              <a:t>Prefab</a:t>
+            </a:r>
+            <a:r>
+              <a:rPr lang="ko-KR" altLang="en-US" dirty="0"/>
+              <a:t>은 어떤 </a:t>
+            </a:r>
+            <a:r>
+              <a:rPr lang="en-US" altLang="ko-KR" dirty="0"/>
+              <a:t>Scene</a:t>
+            </a:r>
+            <a:r>
+              <a:rPr lang="ko-KR" altLang="en-US" dirty="0"/>
+              <a:t>에서든지 드래그</a:t>
+            </a:r>
+            <a:r>
+              <a:rPr lang="en-US" altLang="ko-KR" dirty="0"/>
+              <a:t>&amp;</a:t>
+            </a:r>
+            <a:r>
+              <a:rPr lang="ko-KR" altLang="en-US" dirty="0" err="1"/>
+              <a:t>드랍하면</a:t>
+            </a:r>
+            <a:r>
+              <a:rPr lang="ko-KR" altLang="en-US" dirty="0"/>
+              <a:t> 사용할 수 있다</a:t>
+            </a:r>
+            <a:r>
+              <a:rPr lang="en-US" altLang="ko-KR" dirty="0"/>
+              <a:t>.</a:t>
+            </a:r>
+            <a:endParaRPr lang="ko-KR" altLang="en-US" dirty="0"/>
+          </a:p>
+        </p:txBody>
+      </p:sp>
+    </p:spTree>
+    <p:extLst>
+      <p:ext uri="{BB962C8B-B14F-4D97-AF65-F5344CB8AC3E}">
+        <p14:creationId xmlns:p14="http://schemas.microsoft.com/office/powerpoint/2010/main" val="3646362785"/>
+      </p:ext>
+    </p:extLst>
+  </p:cSld>
+  <p:clrMapOvr>
+    <a:masterClrMapping/>
+  </p:clrMapOvr>
+</p:sld>
+</file>
+
+<file path=ppt/slides/slide8.xml><?xml version="1.0" encoding="utf-8"?>
+<p:sld xmlns:a="http://schemas.openxmlformats.org/drawingml/2006/main" xmlns:r="http://schemas.openxmlformats.org/officeDocument/2006/relationships" xmlns:p="http://schemas.openxmlformats.org/presentationml/2006/main">
+  <p:cSld>
+    <p:spTree>
+      <p:nvGrpSpPr>
+        <p:cNvPr id="1" name=""/>
+        <p:cNvGrpSpPr/>
+        <p:nvPr/>
+      </p:nvGrpSpPr>
+      <p:grpSpPr>
+        <a:xfrm>
+          <a:off x="0" y="0"/>
+          <a:ext cx="0" cy="0"/>
+          <a:chOff x="0" y="0"/>
+          <a:chExt cx="0" cy="0"/>
+        </a:xfrm>
+      </p:grpSpPr>
+      <p:sp>
+        <p:nvSpPr>
+          <p:cNvPr id="2" name="제목 1">
+            <a:extLst>
+              <a:ext uri="{FF2B5EF4-FFF2-40B4-BE49-F238E27FC236}">
+                <a16:creationId xmlns:a16="http://schemas.microsoft.com/office/drawing/2014/main" id="{A994B7AF-0E63-2A80-4C8A-63AE88D262F4}"/>
+              </a:ext>
+            </a:extLst>
+          </p:cNvPr>
+          <p:cNvSpPr>
+            <a:spLocks noGrp="1"/>
+          </p:cNvSpPr>
+          <p:nvPr>
+            <p:ph type="title"/>
+          </p:nvPr>
+        </p:nvSpPr>
+        <p:spPr/>
+        <p:txBody>
+          <a:bodyPr/>
+          <a:lstStyle/>
+          <a:p>
+            <a:r>
+              <a:rPr lang="en-US" altLang="ko-KR" dirty="0"/>
+              <a:t>Post</a:t>
+            </a:r>
+            <a:r>
+              <a:rPr lang="ko-KR" altLang="en-US" dirty="0"/>
+              <a:t> </a:t>
+            </a:r>
+            <a:r>
+              <a:rPr lang="en-US" altLang="ko-KR" dirty="0"/>
+              <a:t>Processing</a:t>
+            </a:r>
+            <a:r>
+              <a:rPr lang="ko-KR" altLang="en-US" dirty="0"/>
+              <a:t> 후처리</a:t>
+            </a:r>
+          </a:p>
+        </p:txBody>
+      </p:sp>
+      <p:sp>
+        <p:nvSpPr>
+          <p:cNvPr id="3" name="내용 개체 틀 2">
+            <a:extLst>
+              <a:ext uri="{FF2B5EF4-FFF2-40B4-BE49-F238E27FC236}">
+                <a16:creationId xmlns:a16="http://schemas.microsoft.com/office/drawing/2014/main" id="{7449A69F-2474-F26B-8FD0-CF76F68B2AB1}"/>
+              </a:ext>
+            </a:extLst>
+          </p:cNvPr>
+          <p:cNvSpPr>
+            <a:spLocks noGrp="1"/>
+          </p:cNvSpPr>
+          <p:nvPr>
+            <p:ph idx="1"/>
+          </p:nvPr>
+        </p:nvSpPr>
+        <p:spPr>
+          <a:xfrm>
+            <a:off x="838200" y="1531620"/>
+            <a:ext cx="10515600" cy="5246370"/>
+          </a:xfrm>
+        </p:spPr>
+        <p:txBody>
+          <a:bodyPr>
+            <a:normAutofit/>
+          </a:bodyPr>
+          <a:lstStyle/>
+          <a:p>
+            <a:r>
+              <a:rPr lang="ko-KR" altLang="en-US" dirty="0"/>
+              <a:t>게임의 퀄리티를 높이기 위한 여러 가지 기능 혹은 작업들을 하면</a:t>
+            </a:r>
+            <a:r>
+              <a:rPr lang="en-US" altLang="ko-KR" dirty="0"/>
+              <a:t>, </a:t>
+            </a:r>
+            <a:r>
+              <a:rPr lang="ko-KR" altLang="en-US" dirty="0"/>
+              <a:t>그걸 적용하는 것을 의미</a:t>
+            </a:r>
+            <a:endParaRPr lang="en-US" altLang="ko-KR" dirty="0"/>
+          </a:p>
+          <a:p>
+            <a:r>
+              <a:rPr lang="en-US" altLang="ko-KR" dirty="0"/>
+              <a:t>Hierarchy</a:t>
+            </a:r>
+            <a:r>
+              <a:rPr lang="ko-KR" altLang="en-US" dirty="0"/>
+              <a:t>에서 </a:t>
+            </a:r>
+            <a:r>
+              <a:rPr lang="en-US" altLang="ko-KR" dirty="0" err="1"/>
+              <a:t>MainCamera</a:t>
+            </a:r>
+            <a:r>
+              <a:rPr lang="ko-KR" altLang="en-US" dirty="0"/>
+              <a:t>의 </a:t>
+            </a:r>
+            <a:r>
+              <a:rPr lang="en-US" altLang="ko-KR" dirty="0"/>
+              <a:t>Camera </a:t>
+            </a:r>
+            <a:r>
+              <a:rPr lang="ko-KR" altLang="en-US" dirty="0"/>
+              <a:t>항목에서 </a:t>
+            </a:r>
+            <a:r>
+              <a:rPr lang="en-US" altLang="ko-KR" dirty="0"/>
+              <a:t>Rendering -&gt; Post Processing</a:t>
+            </a:r>
+            <a:r>
+              <a:rPr lang="ko-KR" altLang="en-US" dirty="0"/>
+              <a:t>을 활성화해주자</a:t>
+            </a:r>
+            <a:r>
+              <a:rPr lang="en-US" altLang="ko-KR" dirty="0"/>
+              <a:t>.</a:t>
+            </a:r>
+          </a:p>
+          <a:p>
+            <a:r>
+              <a:rPr lang="ko-KR" altLang="en-US" dirty="0"/>
+              <a:t>실제 후처리를 담당하는 오브젝트를 생성하기</a:t>
+            </a:r>
+            <a:endParaRPr lang="en-US" altLang="ko-KR" dirty="0"/>
+          </a:p>
+          <a:p>
+            <a:pPr lvl="1"/>
+            <a:r>
+              <a:rPr lang="en-US" altLang="ko-KR" dirty="0"/>
+              <a:t>Hierarchy </a:t>
+            </a:r>
+            <a:r>
+              <a:rPr lang="ko-KR" altLang="en-US" dirty="0"/>
+              <a:t>빈 곳에 </a:t>
+            </a:r>
+            <a:r>
+              <a:rPr lang="ko-KR" altLang="en-US" dirty="0" err="1"/>
+              <a:t>우클릭</a:t>
+            </a:r>
+            <a:r>
+              <a:rPr lang="ko-KR" altLang="en-US" dirty="0"/>
+              <a:t> </a:t>
+            </a:r>
+            <a:r>
+              <a:rPr lang="en-US" altLang="ko-KR" dirty="0"/>
+              <a:t>-&gt; Volume -&gt; Global Volume</a:t>
+            </a:r>
+          </a:p>
+          <a:p>
+            <a:pPr lvl="1"/>
+            <a:r>
+              <a:rPr lang="ko-KR" altLang="en-US" dirty="0"/>
+              <a:t>이 오브젝트의 </a:t>
+            </a:r>
+            <a:r>
+              <a:rPr lang="en-US" altLang="ko-KR" dirty="0"/>
+              <a:t>Volume </a:t>
+            </a:r>
+            <a:r>
+              <a:rPr lang="ko-KR" altLang="en-US" dirty="0"/>
+              <a:t>항목에서 </a:t>
+            </a:r>
+            <a:r>
+              <a:rPr lang="en-US" altLang="ko-KR" dirty="0"/>
+              <a:t>Profile</a:t>
+            </a:r>
+            <a:r>
+              <a:rPr lang="ko-KR" altLang="en-US" dirty="0"/>
+              <a:t>을 </a:t>
+            </a:r>
+            <a:r>
+              <a:rPr lang="en-US" altLang="ko-KR" dirty="0"/>
+              <a:t>‘</a:t>
+            </a:r>
+            <a:r>
+              <a:rPr lang="en-US" altLang="ko-KR" dirty="0" err="1"/>
+              <a:t>GlobalVolumeProfile</a:t>
+            </a:r>
+            <a:r>
+              <a:rPr lang="en-US" altLang="ko-KR" dirty="0"/>
+              <a:t>’</a:t>
+            </a:r>
+            <a:r>
+              <a:rPr lang="ko-KR" altLang="en-US" dirty="0"/>
+              <a:t>을 선택하면 됨</a:t>
+            </a:r>
+            <a:endParaRPr lang="en-US" altLang="ko-KR" dirty="0"/>
+          </a:p>
+          <a:p>
+            <a:pPr lvl="1"/>
+            <a:r>
+              <a:rPr lang="ko-KR" altLang="en-US" dirty="0"/>
+              <a:t>그러면 </a:t>
+            </a:r>
+            <a:r>
+              <a:rPr lang="en-US" altLang="ko-KR" dirty="0" err="1"/>
+              <a:t>Tonemapping</a:t>
+            </a:r>
+            <a:r>
+              <a:rPr lang="ko-KR" altLang="en-US" dirty="0"/>
+              <a:t>과 </a:t>
+            </a:r>
+            <a:r>
+              <a:rPr lang="en-US" altLang="ko-KR" dirty="0"/>
+              <a:t>Bloom </a:t>
+            </a:r>
+            <a:r>
+              <a:rPr lang="ko-KR" altLang="en-US" dirty="0"/>
+              <a:t>항목이 생기는데</a:t>
+            </a:r>
+            <a:r>
+              <a:rPr lang="en-US" altLang="ko-KR" dirty="0"/>
+              <a:t>, </a:t>
+            </a:r>
+            <a:r>
+              <a:rPr lang="ko-KR" altLang="en-US" dirty="0"/>
+              <a:t>여기서 여러 가지 조절을 또 할 수 있다</a:t>
+            </a:r>
+            <a:r>
+              <a:rPr lang="en-US" altLang="ko-KR" dirty="0"/>
+              <a:t>.</a:t>
+            </a:r>
+          </a:p>
+        </p:txBody>
+      </p:sp>
+    </p:spTree>
+    <p:extLst>
+      <p:ext uri="{BB962C8B-B14F-4D97-AF65-F5344CB8AC3E}">
+        <p14:creationId xmlns:p14="http://schemas.microsoft.com/office/powerpoint/2010/main" val="273460658"/>
+      </p:ext>
+    </p:extLst>
+  </p:cSld>
+  <p:clrMapOvr>
+    <a:masterClrMapping/>
+  </p:clrMapOvr>
+</p:sld>
+</file>
+
+<file path=ppt/slides/slide9.xml><?xml version="1.0" encoding="utf-8"?>
+<p:sld xmlns:a="http://schemas.openxmlformats.org/drawingml/2006/main" xmlns:r="http://schemas.openxmlformats.org/officeDocument/2006/relationships" xmlns:p="http://schemas.openxmlformats.org/presentationml/2006/main">
+  <p:cSld>
+    <p:spTree>
+      <p:nvGrpSpPr>
+        <p:cNvPr id="1" name=""/>
+        <p:cNvGrpSpPr/>
+        <p:nvPr/>
+      </p:nvGrpSpPr>
+      <p:grpSpPr>
+        <a:xfrm>
+          <a:off x="0" y="0"/>
+          <a:ext cx="0" cy="0"/>
+          <a:chOff x="0" y="0"/>
+          <a:chExt cx="0" cy="0"/>
+        </a:xfrm>
+      </p:grpSpPr>
+      <p:sp>
+        <p:nvSpPr>
+          <p:cNvPr id="2" name="제목 1">
+            <a:extLst>
+              <a:ext uri="{FF2B5EF4-FFF2-40B4-BE49-F238E27FC236}">
+                <a16:creationId xmlns:a16="http://schemas.microsoft.com/office/drawing/2014/main" id="{569D7B29-B37B-3E2D-D415-976F1138F5DD}"/>
+              </a:ext>
+            </a:extLst>
+          </p:cNvPr>
+          <p:cNvSpPr>
+            <a:spLocks noGrp="1"/>
+          </p:cNvSpPr>
+          <p:nvPr>
+            <p:ph type="title"/>
+          </p:nvPr>
+        </p:nvSpPr>
+        <p:spPr/>
+        <p:txBody>
+          <a:bodyPr>
+            <a:normAutofit/>
+          </a:bodyPr>
+          <a:lstStyle/>
+          <a:p>
+            <a:r>
+              <a:rPr lang="ko-KR" altLang="en-US" sz="2800" b="1" dirty="0"/>
+              <a:t>후처리 여러 효과</a:t>
+            </a:r>
+            <a:r>
+              <a:rPr lang="en-US" altLang="ko-KR" sz="2800" b="1" dirty="0"/>
+              <a:t>(Inspector</a:t>
+            </a:r>
+            <a:r>
+              <a:rPr lang="ko-KR" altLang="en-US" sz="2800" b="1" dirty="0"/>
+              <a:t>에서 </a:t>
+            </a:r>
+            <a:r>
+              <a:rPr lang="en-US" altLang="ko-KR" sz="2800" b="1" dirty="0"/>
+              <a:t>Add Override</a:t>
+            </a:r>
+            <a:r>
+              <a:rPr lang="ko-KR" altLang="en-US" sz="2800" b="1" dirty="0"/>
+              <a:t>에서 추가하면 됨</a:t>
+            </a:r>
+            <a:r>
+              <a:rPr lang="en-US" altLang="ko-KR" sz="2800" b="1" dirty="0"/>
+              <a:t>)</a:t>
+            </a:r>
+            <a:endParaRPr lang="ko-KR" altLang="en-US" sz="2800" b="1" dirty="0"/>
+          </a:p>
+        </p:txBody>
+      </p:sp>
+      <p:sp>
+        <p:nvSpPr>
+          <p:cNvPr id="3" name="내용 개체 틀 2">
+            <a:extLst>
+              <a:ext uri="{FF2B5EF4-FFF2-40B4-BE49-F238E27FC236}">
+                <a16:creationId xmlns:a16="http://schemas.microsoft.com/office/drawing/2014/main" id="{3E951AF2-933E-B98D-E4FD-8FDEF142CC3C}"/>
+              </a:ext>
+            </a:extLst>
+          </p:cNvPr>
+          <p:cNvSpPr>
+            <a:spLocks noGrp="1"/>
+          </p:cNvSpPr>
+          <p:nvPr>
+            <p:ph idx="1"/>
+          </p:nvPr>
+        </p:nvSpPr>
+        <p:spPr>
+          <a:xfrm>
+            <a:off x="838200" y="1825624"/>
+            <a:ext cx="10515600" cy="4860925"/>
+          </a:xfrm>
+        </p:spPr>
+        <p:txBody>
+          <a:bodyPr>
+            <a:normAutofit fontScale="85000" lnSpcReduction="20000"/>
+          </a:bodyPr>
+          <a:lstStyle/>
+          <a:p>
+            <a:r>
+              <a:rPr lang="en-US" altLang="ko-KR" dirty="0"/>
+              <a:t>Vignette : </a:t>
+            </a:r>
+            <a:r>
+              <a:rPr lang="ko-KR" altLang="en-US" dirty="0"/>
+              <a:t>카메라로 보는 듯한 효과</a:t>
+            </a:r>
+            <a:r>
+              <a:rPr lang="en-US" altLang="ko-KR" dirty="0"/>
+              <a:t>(</a:t>
+            </a:r>
+            <a:r>
+              <a:rPr lang="ko-KR" altLang="en-US" dirty="0"/>
+              <a:t>가장자리 둥글게 어둡게 하는 효과</a:t>
+            </a:r>
+            <a:r>
+              <a:rPr lang="en-US" altLang="ko-KR" dirty="0"/>
+              <a:t>)</a:t>
+            </a:r>
+          </a:p>
+          <a:p>
+            <a:r>
+              <a:rPr lang="en-US" altLang="ko-KR" dirty="0"/>
+              <a:t>Motion Blur : </a:t>
+            </a:r>
+            <a:r>
+              <a:rPr lang="ko-KR" altLang="en-US" dirty="0"/>
+              <a:t>캐릭터를 움직이면</a:t>
+            </a:r>
+            <a:r>
+              <a:rPr lang="en-US" altLang="ko-KR" dirty="0"/>
+              <a:t>, </a:t>
+            </a:r>
+            <a:r>
+              <a:rPr lang="ko-KR" altLang="en-US" dirty="0"/>
+              <a:t>잔상이나 약간 </a:t>
+            </a:r>
+            <a:r>
+              <a:rPr lang="ko-KR" altLang="en-US" dirty="0" err="1"/>
+              <a:t>버벅이는</a:t>
+            </a:r>
+            <a:r>
+              <a:rPr lang="ko-KR" altLang="en-US" dirty="0"/>
+              <a:t> 듯한 </a:t>
+            </a:r>
+            <a:r>
+              <a:rPr lang="en-US" altLang="ko-KR" dirty="0"/>
+              <a:t>(</a:t>
+            </a:r>
+            <a:r>
+              <a:rPr lang="ko-KR" altLang="en-US" dirty="0"/>
+              <a:t>카메라로 보는 듯한</a:t>
+            </a:r>
+            <a:r>
+              <a:rPr lang="en-US" altLang="ko-KR" dirty="0"/>
+              <a:t>) </a:t>
+            </a:r>
+            <a:r>
+              <a:rPr lang="ko-KR" altLang="en-US" dirty="0"/>
+              <a:t>효과</a:t>
+            </a:r>
+            <a:r>
+              <a:rPr lang="en-US" altLang="ko-KR" dirty="0"/>
+              <a:t>)</a:t>
+            </a:r>
+          </a:p>
+          <a:p>
+            <a:r>
+              <a:rPr lang="en-US" altLang="ko-KR" dirty="0"/>
+              <a:t>Lens</a:t>
+            </a:r>
+            <a:r>
+              <a:rPr lang="ko-KR" altLang="en-US" dirty="0"/>
+              <a:t> </a:t>
+            </a:r>
+            <a:r>
+              <a:rPr lang="en-US" altLang="ko-KR" dirty="0"/>
+              <a:t>Distortion : </a:t>
+            </a:r>
+            <a:r>
+              <a:rPr lang="ko-KR" altLang="en-US" dirty="0"/>
+              <a:t>카메라 왜곡 효과</a:t>
+            </a:r>
+            <a:r>
+              <a:rPr lang="en-US" altLang="ko-KR" dirty="0"/>
+              <a:t>(</a:t>
+            </a:r>
+            <a:r>
+              <a:rPr lang="ko-KR" altLang="en-US" dirty="0"/>
+              <a:t>볼록</a:t>
+            </a:r>
+            <a:r>
+              <a:rPr lang="en-US" altLang="ko-KR" dirty="0"/>
+              <a:t>, </a:t>
+            </a:r>
+            <a:r>
+              <a:rPr lang="ko-KR" altLang="en-US" dirty="0" err="1"/>
+              <a:t>오목렌즈같은</a:t>
+            </a:r>
+            <a:r>
+              <a:rPr lang="en-US" altLang="ko-KR" dirty="0"/>
+              <a:t>)</a:t>
+            </a:r>
+          </a:p>
+          <a:p>
+            <a:r>
+              <a:rPr lang="en-US" altLang="ko-KR" dirty="0"/>
+              <a:t>Depth Of Field : </a:t>
+            </a:r>
+            <a:r>
+              <a:rPr lang="ko-KR" altLang="en-US" dirty="0"/>
+              <a:t>게임 화질을 </a:t>
+            </a:r>
+            <a:r>
+              <a:rPr lang="en-US" altLang="ko-KR" dirty="0"/>
+              <a:t>4K</a:t>
+            </a:r>
+            <a:r>
+              <a:rPr lang="ko-KR" altLang="en-US" dirty="0"/>
+              <a:t>로 바꿔보면 이 효과가 더 잘 보인다</a:t>
+            </a:r>
+            <a:r>
+              <a:rPr lang="en-US" altLang="ko-KR" dirty="0"/>
+              <a:t>. </a:t>
+            </a:r>
+            <a:r>
+              <a:rPr lang="ko-KR" altLang="en-US" dirty="0"/>
+              <a:t>이 효과는 내가 보고 있는 대상을 더 뚜렷하게 보고</a:t>
+            </a:r>
+            <a:r>
+              <a:rPr lang="en-US" altLang="ko-KR" dirty="0"/>
+              <a:t>, </a:t>
+            </a:r>
+            <a:r>
+              <a:rPr lang="ko-KR" altLang="en-US" dirty="0"/>
+              <a:t>나머지를 좀 흐릿하게 보는 효과</a:t>
+            </a:r>
+            <a:endParaRPr lang="en-US" altLang="ko-KR" dirty="0"/>
+          </a:p>
+          <a:p>
+            <a:r>
+              <a:rPr lang="en-US" altLang="ko-KR" dirty="0"/>
+              <a:t>Film Grain : </a:t>
+            </a:r>
+            <a:r>
+              <a:rPr lang="ko-KR" altLang="en-US" dirty="0" err="1"/>
+              <a:t>영화같은</a:t>
+            </a:r>
+            <a:r>
+              <a:rPr lang="ko-KR" altLang="en-US" dirty="0"/>
+              <a:t> 카메라 효과</a:t>
+            </a:r>
+            <a:endParaRPr lang="en-US" altLang="ko-KR" dirty="0"/>
+          </a:p>
+          <a:p>
+            <a:r>
+              <a:rPr lang="en-US" altLang="ko-KR" dirty="0"/>
+              <a:t>Chromatic Aberration : </a:t>
+            </a:r>
+            <a:r>
+              <a:rPr lang="ko-KR" altLang="en-US" dirty="0" err="1"/>
+              <a:t>색소차</a:t>
+            </a:r>
+            <a:r>
+              <a:rPr lang="ko-KR" altLang="en-US" dirty="0"/>
+              <a:t> 효과</a:t>
+            </a:r>
+            <a:r>
+              <a:rPr lang="en-US" altLang="ko-KR" dirty="0"/>
+              <a:t>(?). </a:t>
+            </a:r>
+            <a:r>
+              <a:rPr lang="ko-KR" altLang="en-US" dirty="0"/>
+              <a:t>뭔가 캐릭터가 어지러움을 느끼거나 약에 취했을 때 화면의 색상이 갈라지는 효과 같은 것</a:t>
+            </a:r>
+            <a:endParaRPr lang="en-US" altLang="ko-KR" dirty="0"/>
+          </a:p>
+          <a:p>
+            <a:r>
+              <a:rPr lang="ko-KR" altLang="en-US" dirty="0"/>
+              <a:t>나머지는 모두 색을 어떻게 나타낼 것인지</a:t>
+            </a:r>
+            <a:r>
+              <a:rPr lang="en-US" altLang="ko-KR" dirty="0"/>
+              <a:t>(</a:t>
+            </a:r>
+            <a:r>
+              <a:rPr lang="ko-KR" altLang="en-US" dirty="0"/>
+              <a:t>노출</a:t>
+            </a:r>
+            <a:r>
+              <a:rPr lang="en-US" altLang="ko-KR" dirty="0"/>
+              <a:t>, </a:t>
+            </a:r>
+            <a:r>
+              <a:rPr lang="ko-KR" altLang="en-US" dirty="0"/>
+              <a:t>대비 등</a:t>
+            </a:r>
+            <a:r>
+              <a:rPr lang="en-US" altLang="ko-KR" dirty="0"/>
+              <a:t>)</a:t>
+            </a:r>
+            <a:r>
+              <a:rPr lang="ko-KR" altLang="en-US" dirty="0"/>
+              <a:t>에 대한 효과</a:t>
+            </a:r>
+            <a:endParaRPr lang="en-US" altLang="ko-KR" dirty="0"/>
+          </a:p>
+          <a:p>
+            <a:endParaRPr lang="en-US" altLang="ko-KR" dirty="0"/>
+          </a:p>
+          <a:p>
+            <a:r>
+              <a:rPr lang="ko-KR" altLang="en-US" dirty="0"/>
+              <a:t>이 후처리는 </a:t>
+            </a:r>
+            <a:r>
+              <a:rPr lang="ko-KR" altLang="en-US" dirty="0" err="1"/>
+              <a:t>계산량에</a:t>
+            </a:r>
+            <a:r>
+              <a:rPr lang="ko-KR" altLang="en-US" dirty="0"/>
+              <a:t> 매우 영향을 많이 미치므로</a:t>
+            </a:r>
+            <a:r>
+              <a:rPr lang="en-US" altLang="ko-KR" dirty="0"/>
+              <a:t>, </a:t>
+            </a:r>
+            <a:r>
+              <a:rPr lang="ko-KR" altLang="en-US" dirty="0"/>
+              <a:t>적당한 선에서만 사용하도록 하자</a:t>
+            </a:r>
+          </a:p>
+        </p:txBody>
+      </p:sp>
+    </p:spTree>
+    <p:extLst>
+      <p:ext uri="{BB962C8B-B14F-4D97-AF65-F5344CB8AC3E}">
+        <p14:creationId xmlns:p14="http://schemas.microsoft.com/office/powerpoint/2010/main" val="3613664226"/>
       </p:ext>
     </p:extLst>
   </p:cSld>

</xml_diff>